<commit_message>
Add customer learning guide and complete repeatability audit
</commit_message>
<xml_diff>
--- a/docs/customer/NetMambaPlus-customer-slides.pptx
+++ b/docs/customer/NetMambaPlus-customer-slides.pptx
@@ -18,6 +18,9 @@
     <p:sldId id="266" r:id="rId18"/>
     <p:sldId id="267" r:id="rId19"/>
     <p:sldId id="268" r:id="rId20"/>
+    <p:sldId id="269" r:id="rId21"/>
+    <p:sldId id="270" r:id="rId22"/>
+    <p:sldId id="271" r:id="rId23"/>
   </p:sldIdLst>
   <p:sldSz cx="12191999" cy="6858000" type="screen4x3"/>
   <p:notesSz cx="6858000" cy="9144000"/>
@@ -818,7 +821,235 @@
           <a:lstStyle/>
           <a:p>
             <a:r>
-              <a:t>The AI research is shared as a reviewed research record, not a raw private conversation. The focused council reviewed the staged plan; it did not independently certify later experiment results, and an older unratified audit remains historical. The command line tools and full measured records let a reviewer inspect the work directly. Third-party data and original weights remain externally obtained assets; hashes and acquisition instructions are included.</a:t>
+              <a:t>The paper studies intrusion detection: recognizing patterns in network traffic that may indicate attacks. NetMamba+ combines byte content, packet sizes and timing. The authors’ repository is a research implementation and asset source. Our repository is a pinned execution and evidence wrapper around that implementation. We preserve all 103 tracked upstream files and seven core source hashes. Compiler compatibility edits are made only in disposable copies used to build Mamba and causal convolution for the newer GB10. We add data/source validation, reproducible commands, strict checkpoint loading, unlabeled inference, measurements and presentation material. The paper reports A100, Torch 2.1.1, batch 64 and learning rate 0.002; our source preset uses GB10, Torch 2.9.1, batch 128 and effective maximum rate 0.001. We have not isolated which differences caused the accuracy gap. The uploaded packet CSVs are not the separate CICIoT2022 flows used for training. Read upstream-comparison.md for the file-level comparison and dataset explanation.</a:t>
+            </a:r>
+          </a:p>
+          <a:p/>
+          <a:p>
+            <a:r>
+              <a:t>Evidence: https://github.com/buffbeefalo/netmambaplus-reproduction/tree/main/docs/customer/evidence</a:t>
+            </a:r>
+          </a:p>
+        </p:txBody>
+      </p:sp>
+      <p:sp>
+        <p:nvSpPr>
+          <p:cNvPr id="4" name="Slide Number Placeholder 3"/>
+          <p:cNvSpPr>
+            <a:spLocks noGrp="1"/>
+          </p:cNvSpPr>
+          <p:nvPr>
+            <p:ph type="sldNum" idx="5" sz="quarter"/>
+          </p:nvPr>
+        </p:nvSpPr>
+        <p:spPr/>
+      </p:sp>
+    </p:spTree>
+  </p:cSld>
+  <p:clrMapOvr>
+    <a:masterClrMapping/>
+  </p:clrMapOvr>
+</p:notes>
+</file>
+
+<file path=ppt/notesSlides/notesSlide14.xml><?xml version="1.0" encoding="utf-8"?>
+<p:notes xmlns:a="http://schemas.openxmlformats.org/drawingml/2006/main" xmlns:p="http://schemas.openxmlformats.org/presentationml/2006/main" xmlns:r="http://schemas.openxmlformats.org/officeDocument/2006/relationships">
+  <p:cSld>
+    <p:spTree>
+      <p:nvGrpSpPr>
+        <p:cNvPr id="1" name=""/>
+        <p:cNvGrpSpPr/>
+        <p:nvPr/>
+      </p:nvGrpSpPr>
+      <p:grpSpPr>
+        <a:xfrm>
+          <a:off x="0" y="0"/>
+          <a:ext cx="0" cy="0"/>
+          <a:chOff x="0" y="0"/>
+          <a:chExt cx="0" cy="0"/>
+        </a:xfrm>
+      </p:grpSpPr>
+      <p:sp>
+        <p:nvSpPr>
+          <p:cNvPr id="2" name="Slide Image Placeholder 1"/>
+          <p:cNvSpPr>
+            <a:spLocks noGrp="1"/>
+          </p:cNvSpPr>
+          <p:nvPr>
+            <p:ph type="sldImg" idx="2"/>
+          </p:nvPr>
+        </p:nvSpPr>
+        <p:spPr/>
+      </p:sp>
+      <p:sp>
+        <p:nvSpPr>
+          <p:cNvPr id="3" name="Notes Placeholder 2"/>
+          <p:cNvSpPr>
+            <a:spLocks noGrp="1"/>
+          </p:cNvSpPr>
+          <p:nvPr>
+            <p:ph type="body" idx="3" sz="quarter"/>
+          </p:nvPr>
+        </p:nvSpPr>
+        <p:spPr/>
+        <p:txBody>
+          <a:bodyPr/>
+          <a:lstStyle/>
+          <a:p>
+            <a:r>
+              <a:t>For the customer meeting, open guide.html and index.html under docs/customer/demo in the downloaded ZIP. No software installation is needed to view those pages. For a CPU check, open a terminal in the project root and run python3 -m unittest discover -s tests -v, followed by python3 tools/verify_package.py. The quickstart explains successful output. For fresh inference, follow the detailed runbook: acquire pinned upstream assets, build the GB10 runtime, run its numerical checks, train a classifier and pass its checkpoint to evaluate.py or predict.py. We do not distribute inherited pretrained weights in the customer ZIP, so it is not a ready-to-run GPU model download. Keep each run in a fresh output directory.</a:t>
+            </a:r>
+          </a:p>
+          <a:p/>
+          <a:p>
+            <a:r>
+              <a:t>Evidence: https://github.com/buffbeefalo/netmambaplus-reproduction/tree/main/docs/customer/evidence</a:t>
+            </a:r>
+          </a:p>
+        </p:txBody>
+      </p:sp>
+      <p:sp>
+        <p:nvSpPr>
+          <p:cNvPr id="4" name="Slide Number Placeholder 3"/>
+          <p:cNvSpPr>
+            <a:spLocks noGrp="1"/>
+          </p:cNvSpPr>
+          <p:nvPr>
+            <p:ph type="sldNum" idx="5" sz="quarter"/>
+          </p:nvPr>
+        </p:nvSpPr>
+        <p:spPr/>
+      </p:sp>
+    </p:spTree>
+  </p:cSld>
+  <p:clrMapOvr>
+    <a:masterClrMapping/>
+  </p:clrMapOvr>
+</p:notes>
+</file>
+
+<file path=ppt/notesSlides/notesSlide15.xml><?xml version="1.0" encoding="utf-8"?>
+<p:notes xmlns:a="http://schemas.openxmlformats.org/drawingml/2006/main" xmlns:p="http://schemas.openxmlformats.org/presentationml/2006/main" xmlns:r="http://schemas.openxmlformats.org/officeDocument/2006/relationships">
+  <p:cSld>
+    <p:spTree>
+      <p:nvGrpSpPr>
+        <p:cNvPr id="1" name=""/>
+        <p:cNvGrpSpPr/>
+        <p:nvPr/>
+      </p:nvGrpSpPr>
+      <p:grpSpPr>
+        <a:xfrm>
+          <a:off x="0" y="0"/>
+          <a:ext cx="0" cy="0"/>
+          <a:chOff x="0" y="0"/>
+          <a:chExt cx="0" cy="0"/>
+        </a:xfrm>
+      </p:grpSpPr>
+      <p:sp>
+        <p:nvSpPr>
+          <p:cNvPr id="2" name="Slide Image Placeholder 1"/>
+          <p:cNvSpPr>
+            <a:spLocks noGrp="1"/>
+          </p:cNvSpPr>
+          <p:nvPr>
+            <p:ph type="sldImg" idx="2"/>
+          </p:nvPr>
+        </p:nvSpPr>
+        <p:spPr/>
+      </p:sp>
+      <p:sp>
+        <p:nvSpPr>
+          <p:cNvPr id="3" name="Notes Placeholder 2"/>
+          <p:cNvSpPr>
+            <a:spLocks noGrp="1"/>
+          </p:cNvSpPr>
+          <p:nvPr>
+            <p:ph type="body" idx="3" sz="quarter"/>
+          </p:nvPr>
+        </p:nvSpPr>
+        <p:spPr/>
+        <p:txBody>
+          <a:bodyPr/>
+          <a:lstStyle/>
+          <a:p>
+            <a:r>
+              <a:t>The CPU suite passed all 54 tests. It checks the harness including failure paths; the package verifier independently recomputes retained predictions and checks artifact identity. The GPU evidence is separate: three full fine-tuning runs, seven numerical checks in each of two environments, strict reloading of every classifier and new evaluation of all three model-only exports. Removing all benchmark labels and predicting the full 1,041-flow test input produced exactly the recorded seed-zero classes and logits in this fresh run. That is a frozen-result check on the same data, not a new independent accuracy result or a guarantee of universal bitwise repeatability. The strict Torch graph-capture probe failed at causal_conv1d_cuda.causal_conv1d_fwd after eager GPU inference passed. Known warnings and unimplemented deployment paths remain visible.</a:t>
+            </a:r>
+          </a:p>
+          <a:p/>
+          <a:p>
+            <a:r>
+              <a:t>Evidence: https://github.com/buffbeefalo/netmambaplus-reproduction/tree/main/docs/customer/evidence</a:t>
+            </a:r>
+          </a:p>
+        </p:txBody>
+      </p:sp>
+      <p:sp>
+        <p:nvSpPr>
+          <p:cNvPr id="4" name="Slide Number Placeholder 3"/>
+          <p:cNvSpPr>
+            <a:spLocks noGrp="1"/>
+          </p:cNvSpPr>
+          <p:nvPr>
+            <p:ph type="sldNum" idx="5" sz="quarter"/>
+          </p:nvPr>
+        </p:nvSpPr>
+        <p:spPr/>
+      </p:sp>
+    </p:spTree>
+  </p:cSld>
+  <p:clrMapOvr>
+    <a:masterClrMapping/>
+  </p:clrMapOvr>
+</p:notes>
+</file>
+
+<file path=ppt/notesSlides/notesSlide16.xml><?xml version="1.0" encoding="utf-8"?>
+<p:notes xmlns:a="http://schemas.openxmlformats.org/drawingml/2006/main" xmlns:p="http://schemas.openxmlformats.org/presentationml/2006/main" xmlns:r="http://schemas.openxmlformats.org/officeDocument/2006/relationships">
+  <p:cSld>
+    <p:spTree>
+      <p:nvGrpSpPr>
+        <p:cNvPr id="1" name=""/>
+        <p:cNvGrpSpPr/>
+        <p:nvPr/>
+      </p:nvGrpSpPr>
+      <p:grpSpPr>
+        <a:xfrm>
+          <a:off x="0" y="0"/>
+          <a:ext cx="0" cy="0"/>
+          <a:chOff x="0" y="0"/>
+          <a:chExt cx="0" cy="0"/>
+        </a:xfrm>
+      </p:grpSpPr>
+      <p:sp>
+        <p:nvSpPr>
+          <p:cNvPr id="2" name="Slide Image Placeholder 1"/>
+          <p:cNvSpPr>
+            <a:spLocks noGrp="1"/>
+          </p:cNvSpPr>
+          <p:nvPr>
+            <p:ph type="sldImg" idx="2"/>
+          </p:nvPr>
+        </p:nvSpPr>
+        <p:spPr/>
+      </p:sp>
+      <p:sp>
+        <p:nvSpPr>
+          <p:cNvPr id="3" name="Notes Placeholder 2"/>
+          <p:cNvSpPr>
+            <a:spLocks noGrp="1"/>
+          </p:cNvSpPr>
+          <p:nvPr>
+            <p:ph type="body" idx="3" sz="quarter"/>
+          </p:nvPr>
+        </p:nvSpPr>
+        <p:spPr/>
+        <p:txBody>
+          <a:bodyPr/>
+          <a:lstStyle/>
+          <a:p>
+            <a:r>
+              <a:t>The AI research is shared as a reviewed research record, not a raw private conversation. The focused council reviewed the staged plan. Later audit reviews and their exact outcomes are recorded separately with their evidence limits; they are not independent GPU certification. Earlier unratified reviews remain historical. The command line tools and full measured records let a reviewer inspect the work directly. Third-party data and original weights remain externally obtained assets; hashes and acquisition instructions are included.</a:t>
             </a:r>
           </a:p>
           <a:p/>
@@ -1198,7 +1429,7 @@
           <a:lstStyle/>
           <a:p>
             <a:r>
-              <a:t>Accuracy is correct predictions divided by test rows. Weighted F1 weights each class by its number of true examples. Macro F1 treats every class equally, so a small weak class can lower macro F1 more strongly. The table reports all three declared seeds; the mean and sample standard deviation describe seed variability on the same dataset, not uncertainty across customer networks. The paper number is not our measurement and is not a directly controlled comparison. The full source-based experiment and strict re-evaluation are complete even if their scores do not match the paper.</a:t>
+              <a:t>Our measured test accuracies were 91.26 percent for seed zero, 84.05 percent for seed one and 84.63 percent for seed two: 86.65% mean, with a sample standard deviation of 4.00 percentage points. The paper reports 97.50 percent; we did not reproduce that score, and we have not isolated the reason for the gap. Accuracy is correct predictions divided by test rows. Weighted F1 weights each class by its number of true examples. Macro F1 treats every class equally, so a small weak class can lower macro F1 more strongly. The table reports all three declared seeds; the mean and sample standard deviation describe seed variability on the same dataset, not uncertainty across customer networks. The paper number is not our measurement and is not a directly controlled comparison. The full source-based experiment and strict re-evaluation are complete even if their scores do not match the paper.</a:t>
             </a:r>
           </a:p>
           <a:p/>
@@ -8137,7 +8368,7 @@
               </a:defRPr>
             </a:pPr>
             <a:r>
-              <a:t>APPENDIX / WHERE TO VERIFY IT</a:t>
+              <a:t>APPENDIX / COMPARED WITH THE AUTHORS’ REPOSITORY</a:t>
             </a:r>
           </a:p>
         </p:txBody>
@@ -8176,7 +8407,7 @@
               </a:defRPr>
             </a:pPr>
             <a:r>
-              <a:t>Every measured claim has a saved artifact</a:t>
+              <a:t>Keep the model; add a verified execution route</a:t>
             </a:r>
           </a:p>
         </p:txBody>
@@ -8215,7 +8446,7 @@
               </a:defRPr>
             </a:pPr>
             <a:r>
-              <a:t>The repository is the handoff: explanation, editable files, commands and reviewed evidence.</a:t>
+              <a:t>The paper proposes a method. The authors release research code and assets. This repo records a measured port.</a:t>
             </a:r>
           </a:p>
         </p:txBody>
@@ -8340,7 +8571,7 @@
               </a:defRPr>
             </a:pPr>
             <a:r>
-              <a:t>Start here</a:t>
+              <a:t>Authors’ research</a:t>
             </a:r>
           </a:p>
         </p:txBody>
@@ -8371,7 +8602,7 @@
               <a:spcAft>
                 <a:spcPts val="900"/>
               </a:spcAft>
-              <a:defRPr sz="1600" b="0">
+              <a:defRPr sz="1700" b="0">
                 <a:solidFill>
                   <a:srgbClr val="132C38"/>
                 </a:solidFill>
@@ -8379,15 +8610,15 @@
               </a:defRPr>
             </a:pPr>
             <a:r>
-              <a:t>docs/customer/README.md</a:t>
-            </a:r>
-          </a:p>
-          <a:p>
-            <a:pPr>
-              <a:spcAft>
-                <a:spcPts val="900"/>
-              </a:spcAft>
-              <a:defRPr sz="1600" b="0">
+              <a:t>Original NetMamba+ model</a:t>
+            </a:r>
+          </a:p>
+          <a:p>
+            <a:pPr>
+              <a:spcAft>
+                <a:spcPts val="900"/>
+              </a:spcAft>
+              <a:defRPr sz="1700" b="0">
                 <a:solidFill>
                   <a:srgbClr val="132C38"/>
                 </a:solidFill>
@@ -8395,15 +8626,15 @@
               </a:defRPr>
             </a:pPr>
             <a:r>
-              <a:t>Briefing PDF + PowerPoint + slide PDF</a:t>
-            </a:r>
-          </a:p>
-          <a:p>
-            <a:pPr>
-              <a:spcAft>
-                <a:spcPts val="900"/>
-              </a:spcAft>
-              <a:defRPr sz="1600" b="0">
+              <a:t>Native loader and engine</a:t>
+            </a:r>
+          </a:p>
+          <a:p>
+            <a:pPr>
+              <a:spcAft>
+                <a:spcPts val="900"/>
+              </a:spcAft>
+              <a:defRPr sz="1700" b="0">
                 <a:solidFill>
                   <a:srgbClr val="132C38"/>
                 </a:solidFill>
@@ -8411,7 +8642,23 @@
               </a:defRPr>
             </a:pPr>
             <a:r>
-              <a:t>Runbook + talk track + recorded demo</a:t>
+              <a:t>Compatible flow data</a:t>
+            </a:r>
+          </a:p>
+          <a:p>
+            <a:pPr>
+              <a:spcAft>
+                <a:spcPts val="900"/>
+              </a:spcAft>
+              <a:defRPr sz="1700" b="0">
+                <a:solidFill>
+                  <a:srgbClr val="132C38"/>
+                </a:solidFill>
+                <a:latin typeface="DejaVu Sans"/>
+              </a:defRPr>
+            </a:pPr>
+            <a:r>
+              <a:t>Pretrained encoder weights</a:t>
             </a:r>
           </a:p>
         </p:txBody>
@@ -8536,7 +8783,7 @@
               </a:defRPr>
             </a:pPr>
             <a:r>
-              <a:t>Verify results</a:t>
+              <a:t>Our additions</a:t>
             </a:r>
           </a:p>
         </p:txBody>
@@ -8567,7 +8814,7 @@
               <a:spcAft>
                 <a:spcPts val="900"/>
               </a:spcAft>
-              <a:defRPr sz="1600" b="0">
+              <a:defRPr sz="1700" b="0">
                 <a:solidFill>
                   <a:srgbClr val="132C38"/>
                 </a:solidFill>
@@ -8575,15 +8822,15 @@
               </a:defRPr>
             </a:pPr>
             <a:r>
-              <a:t>evidence/results.json</a:t>
-            </a:r>
-          </a:p>
-          <a:p>
-            <a:pPr>
-              <a:spcAft>
-                <a:spcPts val="900"/>
-              </a:spcAft>
-              <a:defRPr sz="1600" b="0">
+              <a:t>Source and asset checks</a:t>
+            </a:r>
+          </a:p>
+          <a:p>
+            <a:pPr>
+              <a:spcAft>
+                <a:spcPts val="900"/>
+              </a:spcAft>
+              <a:defRPr sz="1700" b="0">
                 <a:solidFill>
                   <a:srgbClr val="132C38"/>
                 </a:solidFill>
@@ -8591,15 +8838,15 @@
               </a:defRPr>
             </a:pPr>
             <a:r>
-              <a:t>Per-seed manifests, epoch logs and predictions</a:t>
-            </a:r>
-          </a:p>
-          <a:p>
-            <a:pPr>
-              <a:spcAft>
-                <a:spcPts val="900"/>
-              </a:spcAft>
-              <a:defRPr sz="1600" b="0">
+              <a:t>GB10 build support</a:t>
+            </a:r>
+          </a:p>
+          <a:p>
+            <a:pPr>
+              <a:spcAft>
+                <a:spcPts val="900"/>
+              </a:spcAft>
+              <a:defRPr sz="1700" b="0">
                 <a:solidFill>
                   <a:srgbClr val="132C38"/>
                 </a:solidFill>
@@ -8607,7 +8854,23 @@
               </a:defRPr>
             </a:pPr>
             <a:r>
-              <a:t>Runtime parity + build records + benchmark</a:t>
+              <a:t>Strict evaluation + prediction</a:t>
+            </a:r>
+          </a:p>
+          <a:p>
+            <a:pPr>
+              <a:spcAft>
+                <a:spcPts val="900"/>
+              </a:spcAft>
+              <a:defRPr sz="1700" b="0">
+                <a:solidFill>
+                  <a:srgbClr val="132C38"/>
+                </a:solidFill>
+                <a:latin typeface="DejaVu Sans"/>
+              </a:defRPr>
+            </a:pPr>
+            <a:r>
+              <a:t>Replay, results and guides</a:t>
             </a:r>
           </a:p>
         </p:txBody>
@@ -8732,7 +8995,7 @@
               </a:defRPr>
             </a:pPr>
             <a:r>
-              <a:t>Read the research</a:t>
+              <a:t>Disclosed changes</a:t>
             </a:r>
           </a:p>
         </p:txBody>
@@ -8763,7 +9026,7 @@
               <a:spcAft>
                 <a:spcPts val="900"/>
               </a:spcAft>
-              <a:defRPr sz="1600" b="0">
+              <a:defRPr sz="1700" b="0">
                 <a:solidFill>
                   <a:srgbClr val="132C38"/>
                 </a:solidFill>
@@ -8771,15 +9034,15 @@
               </a:defRPr>
             </a:pPr>
             <a:r>
-              <a:t>docs/research/research-record.md</a:t>
-            </a:r>
-          </a:p>
-          <a:p>
-            <a:pPr>
-              <a:spcAft>
-                <a:spcPts val="900"/>
-              </a:spcAft>
-              <a:defRPr sz="1600" b="0">
+              <a:t>Compiler edits in build copies</a:t>
+            </a:r>
+          </a:p>
+          <a:p>
+            <a:pPr>
+              <a:spcAft>
+                <a:spcPts val="900"/>
+              </a:spcAft>
+              <a:defRPr sz="1700" b="0">
                 <a:solidFill>
                   <a:srgbClr val="132C38"/>
                 </a:solidFill>
@@ -8787,15 +9050,15 @@
               </a:defRPr>
             </a:pPr>
             <a:r>
-              <a:t>Pinned paper/source links</a:t>
-            </a:r>
-          </a:p>
-          <a:p>
-            <a:pPr>
-              <a:spcAft>
-                <a:spcPts val="900"/>
-              </a:spcAft>
-              <a:defRPr sz="1600" b="0">
+              <a:t>New GPU / Torch runtime</a:t>
+            </a:r>
+          </a:p>
+          <a:p>
+            <a:pPr>
+              <a:spcAft>
+                <a:spcPts val="900"/>
+              </a:spcAft>
+              <a:defRPr sz="1700" b="0">
                 <a:solidFill>
                   <a:srgbClr val="132C38"/>
                 </a:solidFill>
@@ -8803,7 +9066,23 @@
               </a:defRPr>
             </a:pPr>
             <a:r>
-              <a:t>Exact council decision and its evidence limits</a:t>
+              <a:t>Source batch and rate recipe</a:t>
+            </a:r>
+          </a:p>
+          <a:p>
+            <a:pPr>
+              <a:spcAft>
+                <a:spcPts val="900"/>
+              </a:spcAft>
+              <a:defRPr sz="1700" b="0">
+                <a:solidFill>
+                  <a:srgbClr val="132C38"/>
+                </a:solidFill>
+                <a:latin typeface="DejaVu Sans"/>
+              </a:defRPr>
+            </a:pPr>
+            <a:r>
+              <a:t>Unknown pretraining history</a:t>
             </a:r>
           </a:p>
         </p:txBody>
@@ -8885,7 +9164,7 @@
               </a:defRPr>
             </a:pPr>
             <a:r>
-              <a:t>github.com/buffbeefalo/netmambaplus-reproduction</a:t>
+              <a:t>The original model and loader checkout is unchanged. Runtime and experiment differences prevent an exact paper reproduction claim.</a:t>
             </a:r>
           </a:p>
         </p:txBody>
@@ -8967,6 +9246,2793 @@
             </a:pPr>
             <a:r>
               <a:t>13</a:t>
+            </a:r>
+          </a:p>
+        </p:txBody>
+      </p:sp>
+    </p:spTree>
+  </p:cSld>
+  <p:clrMapOvr>
+    <a:masterClrMapping/>
+  </p:clrMapOvr>
+</p:sld>
+</file>
+
+<file path=ppt/slides/slide14.xml><?xml version="1.0" encoding="utf-8"?>
+<p:sld xmlns:a="http://schemas.openxmlformats.org/drawingml/2006/main" xmlns:p="http://schemas.openxmlformats.org/presentationml/2006/main" xmlns:r="http://schemas.openxmlformats.org/officeDocument/2006/relationships">
+  <p:cSld>
+    <p:spTree>
+      <p:nvGrpSpPr>
+        <p:cNvPr id="1" name=""/>
+        <p:cNvGrpSpPr/>
+        <p:nvPr/>
+      </p:nvGrpSpPr>
+      <p:grpSpPr/>
+      <p:sp>
+        <p:nvSpPr>
+          <p:cNvPr id="2" name="Rectangle 1"/>
+          <p:cNvSpPr/>
+          <p:nvPr/>
+        </p:nvSpPr>
+        <p:spPr>
+          <a:xfrm>
+            <a:off x="0" y="0"/>
+            <a:ext cx="12191999" cy="6858000"/>
+          </a:xfrm>
+          <a:prstGeom prst="rect">
+            <a:avLst/>
+          </a:prstGeom>
+          <a:solidFill>
+            <a:srgbClr val="F4F1E8"/>
+          </a:solidFill>
+          <a:ln>
+            <a:noFill/>
+          </a:ln>
+        </p:spPr>
+        <p:style>
+          <a:lnRef idx="1">
+            <a:schemeClr val="accent1"/>
+          </a:lnRef>
+          <a:fillRef idx="3">
+            <a:schemeClr val="accent1"/>
+          </a:fillRef>
+          <a:effectRef idx="2">
+            <a:schemeClr val="accent1"/>
+          </a:effectRef>
+          <a:fontRef idx="minor">
+            <a:schemeClr val="lt1"/>
+          </a:fontRef>
+        </p:style>
+        <p:txBody>
+          <a:bodyPr rtlCol="0" anchor="ctr"/>
+          <a:lstStyle/>
+          <a:p>
+            <a:pPr algn="ctr"/>
+          </a:p>
+        </p:txBody>
+      </p:sp>
+      <p:sp>
+        <p:nvSpPr>
+          <p:cNvPr id="3" name="TextBox 2"/>
+          <p:cNvSpPr txBox="1"/>
+          <p:nvPr/>
+        </p:nvSpPr>
+        <p:spPr>
+          <a:xfrm>
+            <a:off x="594360" y="338328"/>
+            <a:ext cx="10789920" cy="274320"/>
+          </a:xfrm>
+          <a:prstGeom prst="rect">
+            <a:avLst/>
+          </a:prstGeom>
+          <a:noFill/>
+        </p:spPr>
+        <p:txBody>
+          <a:bodyPr wrap="square" lIns="18288" rIns="18288" tIns="0" bIns="0">
+            <a:spAutoFit/>
+          </a:bodyPr>
+          <a:lstStyle/>
+          <a:p>
+            <a:pPr>
+              <a:spcAft>
+                <a:spcPts val="900"/>
+              </a:spcAft>
+              <a:defRPr sz="1100" b="1">
+                <a:solidFill>
+                  <a:srgbClr val="007C78"/>
+                </a:solidFill>
+                <a:latin typeface="DejaVu Sans"/>
+              </a:defRPr>
+            </a:pPr>
+            <a:r>
+              <a:t>12 / SET UP AND USE IT</a:t>
+            </a:r>
+          </a:p>
+        </p:txBody>
+      </p:sp>
+      <p:sp>
+        <p:nvSpPr>
+          <p:cNvPr id="4" name="TextBox 3"/>
+          <p:cNvSpPr txBox="1"/>
+          <p:nvPr/>
+        </p:nvSpPr>
+        <p:spPr>
+          <a:xfrm>
+            <a:off x="594360" y="841248"/>
+            <a:ext cx="10972800" cy="621792"/>
+          </a:xfrm>
+          <a:prstGeom prst="rect">
+            <a:avLst/>
+          </a:prstGeom>
+          <a:noFill/>
+        </p:spPr>
+        <p:txBody>
+          <a:bodyPr wrap="square" lIns="18288" rIns="18288" tIns="0" bIns="0">
+            <a:spAutoFit/>
+          </a:bodyPr>
+          <a:lstStyle/>
+          <a:p>
+            <a:pPr>
+              <a:spcAft>
+                <a:spcPts val="900"/>
+              </a:spcAft>
+              <a:defRPr sz="3400" b="0">
+                <a:solidFill>
+                  <a:srgbClr val="132C38"/>
+                </a:solidFill>
+                <a:latin typeface="Liberation Serif"/>
+              </a:defRPr>
+            </a:pPr>
+            <a:r>
+              <a:t>Choose the route that matches your goal</a:t>
+            </a:r>
+          </a:p>
+        </p:txBody>
+      </p:sp>
+      <p:sp>
+        <p:nvSpPr>
+          <p:cNvPr id="5" name="TextBox 4"/>
+          <p:cNvSpPr txBox="1"/>
+          <p:nvPr/>
+        </p:nvSpPr>
+        <p:spPr>
+          <a:xfrm>
+            <a:off x="594360" y="1600200"/>
+            <a:ext cx="10881360" cy="548640"/>
+          </a:xfrm>
+          <a:prstGeom prst="rect">
+            <a:avLst/>
+          </a:prstGeom>
+          <a:noFill/>
+        </p:spPr>
+        <p:txBody>
+          <a:bodyPr wrap="square" lIns="18288" rIns="18288" tIns="0" bIns="0">
+            <a:spAutoFit/>
+          </a:bodyPr>
+          <a:lstStyle/>
+          <a:p>
+            <a:pPr>
+              <a:spcAft>
+                <a:spcPts val="900"/>
+              </a:spcAft>
+              <a:defRPr sz="1600" b="0">
+                <a:solidFill>
+                  <a:srgbClr val="516774"/>
+                </a:solidFill>
+                <a:latin typeface="DejaVu Sans"/>
+              </a:defRPr>
+            </a:pPr>
+            <a:r>
+              <a:t>Viewing, verifying and running the model have different requirements.</a:t>
+            </a:r>
+          </a:p>
+        </p:txBody>
+      </p:sp>
+      <p:sp>
+        <p:nvSpPr>
+          <p:cNvPr id="6" name="Rectangle 5"/>
+          <p:cNvSpPr/>
+          <p:nvPr/>
+        </p:nvSpPr>
+        <p:spPr>
+          <a:xfrm>
+            <a:off x="594360" y="2423160"/>
+            <a:ext cx="3532632" cy="2880360"/>
+          </a:xfrm>
+          <a:prstGeom prst="rect">
+            <a:avLst/>
+          </a:prstGeom>
+          <a:solidFill>
+            <a:srgbClr val="FFFFFF"/>
+          </a:solidFill>
+          <a:ln>
+            <a:noFill/>
+          </a:ln>
+        </p:spPr>
+        <p:style>
+          <a:lnRef idx="1">
+            <a:schemeClr val="accent1"/>
+          </a:lnRef>
+          <a:fillRef idx="3">
+            <a:schemeClr val="accent1"/>
+          </a:fillRef>
+          <a:effectRef idx="2">
+            <a:schemeClr val="accent1"/>
+          </a:effectRef>
+          <a:fontRef idx="minor">
+            <a:schemeClr val="lt1"/>
+          </a:fontRef>
+        </p:style>
+        <p:txBody>
+          <a:bodyPr rtlCol="0" anchor="ctr"/>
+          <a:lstStyle/>
+          <a:p>
+            <a:pPr algn="ctr"/>
+          </a:p>
+        </p:txBody>
+      </p:sp>
+      <p:sp>
+        <p:nvSpPr>
+          <p:cNvPr id="7" name="Rectangle 6"/>
+          <p:cNvSpPr/>
+          <p:nvPr/>
+        </p:nvSpPr>
+        <p:spPr>
+          <a:xfrm>
+            <a:off x="594360" y="2423160"/>
+            <a:ext cx="3532632" cy="50292"/>
+          </a:xfrm>
+          <a:prstGeom prst="rect">
+            <a:avLst/>
+          </a:prstGeom>
+          <a:solidFill>
+            <a:srgbClr val="007C78"/>
+          </a:solidFill>
+          <a:ln>
+            <a:noFill/>
+          </a:ln>
+        </p:spPr>
+        <p:style>
+          <a:lnRef idx="1">
+            <a:schemeClr val="accent1"/>
+          </a:lnRef>
+          <a:fillRef idx="3">
+            <a:schemeClr val="accent1"/>
+          </a:fillRef>
+          <a:effectRef idx="2">
+            <a:schemeClr val="accent1"/>
+          </a:effectRef>
+          <a:fontRef idx="minor">
+            <a:schemeClr val="lt1"/>
+          </a:fontRef>
+        </p:style>
+        <p:txBody>
+          <a:bodyPr rtlCol="0" anchor="ctr"/>
+          <a:lstStyle/>
+          <a:p>
+            <a:pPr algn="ctr"/>
+          </a:p>
+        </p:txBody>
+      </p:sp>
+      <p:sp>
+        <p:nvSpPr>
+          <p:cNvPr id="8" name="TextBox 7"/>
+          <p:cNvSpPr txBox="1"/>
+          <p:nvPr/>
+        </p:nvSpPr>
+        <p:spPr>
+          <a:xfrm>
+            <a:off x="795528" y="2606040"/>
+            <a:ext cx="3130296" cy="457200"/>
+          </a:xfrm>
+          <a:prstGeom prst="rect">
+            <a:avLst/>
+          </a:prstGeom>
+          <a:noFill/>
+        </p:spPr>
+        <p:txBody>
+          <a:bodyPr wrap="square" lIns="18288" rIns="18288" tIns="0" bIns="0">
+            <a:spAutoFit/>
+          </a:bodyPr>
+          <a:lstStyle/>
+          <a:p>
+            <a:pPr>
+              <a:spcAft>
+                <a:spcPts val="900"/>
+              </a:spcAft>
+              <a:defRPr sz="2100" b="1">
+                <a:solidFill>
+                  <a:srgbClr val="007C78"/>
+                </a:solidFill>
+                <a:latin typeface="DejaVu Sans"/>
+              </a:defRPr>
+            </a:pPr>
+            <a:r>
+              <a:t>Present now</a:t>
+            </a:r>
+          </a:p>
+        </p:txBody>
+      </p:sp>
+      <p:sp>
+        <p:nvSpPr>
+          <p:cNvPr id="9" name="TextBox 8"/>
+          <p:cNvSpPr txBox="1"/>
+          <p:nvPr/>
+        </p:nvSpPr>
+        <p:spPr>
+          <a:xfrm>
+            <a:off x="795528" y="3264408"/>
+            <a:ext cx="3130296" cy="1920239"/>
+          </a:xfrm>
+          <a:prstGeom prst="rect">
+            <a:avLst/>
+          </a:prstGeom>
+          <a:noFill/>
+        </p:spPr>
+        <p:txBody>
+          <a:bodyPr wrap="square" lIns="18288" rIns="18288" tIns="0" bIns="0">
+            <a:spAutoFit/>
+          </a:bodyPr>
+          <a:lstStyle/>
+          <a:p>
+            <a:pPr>
+              <a:spcAft>
+                <a:spcPts val="900"/>
+              </a:spcAft>
+              <a:defRPr sz="1700" b="0">
+                <a:solidFill>
+                  <a:srgbClr val="132C38"/>
+                </a:solidFill>
+                <a:latin typeface="DejaVu Sans"/>
+              </a:defRPr>
+            </a:pPr>
+            <a:r>
+              <a:t>Open the guide and recorded replay in a browser.</a:t>
+            </a:r>
+          </a:p>
+          <a:p>
+            <a:pPr>
+              <a:spcAft>
+                <a:spcPts val="900"/>
+              </a:spcAft>
+              <a:defRPr sz="1700" b="0">
+                <a:solidFill>
+                  <a:srgbClr val="132C38"/>
+                </a:solidFill>
+                <a:latin typeface="DejaVu Sans"/>
+              </a:defRPr>
+            </a:pPr>
+            <a:r>
+              <a:t>Download the ZIP for offline use.</a:t>
+            </a:r>
+          </a:p>
+          <a:p>
+            <a:pPr>
+              <a:spcAft>
+                <a:spcPts val="900"/>
+              </a:spcAft>
+              <a:defRPr sz="1700" b="0">
+                <a:solidFill>
+                  <a:srgbClr val="132C38"/>
+                </a:solidFill>
+                <a:latin typeface="DejaVu Sans"/>
+              </a:defRPr>
+            </a:pPr>
+            <a:r>
+              <a:t>No Python or GPU needed.</a:t>
+            </a:r>
+          </a:p>
+        </p:txBody>
+      </p:sp>
+      <p:sp>
+        <p:nvSpPr>
+          <p:cNvPr id="10" name="Rectangle 9"/>
+          <p:cNvSpPr/>
+          <p:nvPr/>
+        </p:nvSpPr>
+        <p:spPr>
+          <a:xfrm>
+            <a:off x="4328160" y="2423160"/>
+            <a:ext cx="3532632" cy="2880360"/>
+          </a:xfrm>
+          <a:prstGeom prst="rect">
+            <a:avLst/>
+          </a:prstGeom>
+          <a:solidFill>
+            <a:srgbClr val="FFFFFF"/>
+          </a:solidFill>
+          <a:ln>
+            <a:noFill/>
+          </a:ln>
+        </p:spPr>
+        <p:style>
+          <a:lnRef idx="1">
+            <a:schemeClr val="accent1"/>
+          </a:lnRef>
+          <a:fillRef idx="3">
+            <a:schemeClr val="accent1"/>
+          </a:fillRef>
+          <a:effectRef idx="2">
+            <a:schemeClr val="accent1"/>
+          </a:effectRef>
+          <a:fontRef idx="minor">
+            <a:schemeClr val="lt1"/>
+          </a:fontRef>
+        </p:style>
+        <p:txBody>
+          <a:bodyPr rtlCol="0" anchor="ctr"/>
+          <a:lstStyle/>
+          <a:p>
+            <a:pPr algn="ctr"/>
+          </a:p>
+        </p:txBody>
+      </p:sp>
+      <p:sp>
+        <p:nvSpPr>
+          <p:cNvPr id="11" name="Rectangle 10"/>
+          <p:cNvSpPr/>
+          <p:nvPr/>
+        </p:nvSpPr>
+        <p:spPr>
+          <a:xfrm>
+            <a:off x="4328160" y="2423160"/>
+            <a:ext cx="3532632" cy="50292"/>
+          </a:xfrm>
+          <a:prstGeom prst="rect">
+            <a:avLst/>
+          </a:prstGeom>
+          <a:solidFill>
+            <a:srgbClr val="007C78"/>
+          </a:solidFill>
+          <a:ln>
+            <a:noFill/>
+          </a:ln>
+        </p:spPr>
+        <p:style>
+          <a:lnRef idx="1">
+            <a:schemeClr val="accent1"/>
+          </a:lnRef>
+          <a:fillRef idx="3">
+            <a:schemeClr val="accent1"/>
+          </a:fillRef>
+          <a:effectRef idx="2">
+            <a:schemeClr val="accent1"/>
+          </a:effectRef>
+          <a:fontRef idx="minor">
+            <a:schemeClr val="lt1"/>
+          </a:fontRef>
+        </p:style>
+        <p:txBody>
+          <a:bodyPr rtlCol="0" anchor="ctr"/>
+          <a:lstStyle/>
+          <a:p>
+            <a:pPr algn="ctr"/>
+          </a:p>
+        </p:txBody>
+      </p:sp>
+      <p:sp>
+        <p:nvSpPr>
+          <p:cNvPr id="12" name="TextBox 11"/>
+          <p:cNvSpPr txBox="1"/>
+          <p:nvPr/>
+        </p:nvSpPr>
+        <p:spPr>
+          <a:xfrm>
+            <a:off x="4529328" y="2606040"/>
+            <a:ext cx="3130296" cy="457200"/>
+          </a:xfrm>
+          <a:prstGeom prst="rect">
+            <a:avLst/>
+          </a:prstGeom>
+          <a:noFill/>
+        </p:spPr>
+        <p:txBody>
+          <a:bodyPr wrap="square" lIns="18288" rIns="18288" tIns="0" bIns="0">
+            <a:spAutoFit/>
+          </a:bodyPr>
+          <a:lstStyle/>
+          <a:p>
+            <a:pPr>
+              <a:spcAft>
+                <a:spcPts val="900"/>
+              </a:spcAft>
+              <a:defRPr sz="2100" b="1">
+                <a:solidFill>
+                  <a:srgbClr val="007C78"/>
+                </a:solidFill>
+                <a:latin typeface="DejaVu Sans"/>
+              </a:defRPr>
+            </a:pPr>
+            <a:r>
+              <a:t>Check the package</a:t>
+            </a:r>
+          </a:p>
+        </p:txBody>
+      </p:sp>
+      <p:sp>
+        <p:nvSpPr>
+          <p:cNvPr id="13" name="TextBox 12"/>
+          <p:cNvSpPr txBox="1"/>
+          <p:nvPr/>
+        </p:nvSpPr>
+        <p:spPr>
+          <a:xfrm>
+            <a:off x="4529328" y="3264408"/>
+            <a:ext cx="3130296" cy="1920239"/>
+          </a:xfrm>
+          <a:prstGeom prst="rect">
+            <a:avLst/>
+          </a:prstGeom>
+          <a:noFill/>
+        </p:spPr>
+        <p:txBody>
+          <a:bodyPr wrap="square" lIns="18288" rIns="18288" tIns="0" bIns="0">
+            <a:spAutoFit/>
+          </a:bodyPr>
+          <a:lstStyle/>
+          <a:p>
+            <a:pPr>
+              <a:spcAft>
+                <a:spcPts val="900"/>
+              </a:spcAft>
+              <a:defRPr sz="1700" b="0">
+                <a:solidFill>
+                  <a:srgbClr val="132C38"/>
+                </a:solidFill>
+                <a:latin typeface="DejaVu Sans"/>
+              </a:defRPr>
+            </a:pPr>
+            <a:r>
+              <a:t>Clone or unzip the project.</a:t>
+            </a:r>
+          </a:p>
+          <a:p>
+            <a:pPr>
+              <a:spcAft>
+                <a:spcPts val="900"/>
+              </a:spcAft>
+              <a:defRPr sz="1700" b="0">
+                <a:solidFill>
+                  <a:srgbClr val="132C38"/>
+                </a:solidFill>
+                <a:latin typeface="DejaVu Sans"/>
+              </a:defRPr>
+            </a:pPr>
+            <a:r>
+              <a:t>Use Python 3.10 or newer.</a:t>
+            </a:r>
+          </a:p>
+          <a:p>
+            <a:pPr>
+              <a:spcAft>
+                <a:spcPts val="900"/>
+              </a:spcAft>
+              <a:defRPr sz="1700" b="0">
+                <a:solidFill>
+                  <a:srgbClr val="132C38"/>
+                </a:solidFill>
+                <a:latin typeface="DejaVu Sans"/>
+              </a:defRPr>
+            </a:pPr>
+            <a:r>
+              <a:t>Run the CPU tests and package verifier.</a:t>
+            </a:r>
+          </a:p>
+          <a:p>
+            <a:pPr>
+              <a:spcAft>
+                <a:spcPts val="900"/>
+              </a:spcAft>
+              <a:defRPr sz="1700" b="0">
+                <a:solidFill>
+                  <a:srgbClr val="132C38"/>
+                </a:solidFill>
+                <a:latin typeface="DejaVu Sans"/>
+              </a:defRPr>
+            </a:pPr>
+            <a:r>
+              <a:t>No training assets needed.</a:t>
+            </a:r>
+          </a:p>
+        </p:txBody>
+      </p:sp>
+      <p:sp>
+        <p:nvSpPr>
+          <p:cNvPr id="14" name="Rectangle 13"/>
+          <p:cNvSpPr/>
+          <p:nvPr/>
+        </p:nvSpPr>
+        <p:spPr>
+          <a:xfrm>
+            <a:off x="8061960" y="2423160"/>
+            <a:ext cx="3532632" cy="2880360"/>
+          </a:xfrm>
+          <a:prstGeom prst="rect">
+            <a:avLst/>
+          </a:prstGeom>
+          <a:solidFill>
+            <a:srgbClr val="FFFFFF"/>
+          </a:solidFill>
+          <a:ln>
+            <a:noFill/>
+          </a:ln>
+        </p:spPr>
+        <p:style>
+          <a:lnRef idx="1">
+            <a:schemeClr val="accent1"/>
+          </a:lnRef>
+          <a:fillRef idx="3">
+            <a:schemeClr val="accent1"/>
+          </a:fillRef>
+          <a:effectRef idx="2">
+            <a:schemeClr val="accent1"/>
+          </a:effectRef>
+          <a:fontRef idx="minor">
+            <a:schemeClr val="lt1"/>
+          </a:fontRef>
+        </p:style>
+        <p:txBody>
+          <a:bodyPr rtlCol="0" anchor="ctr"/>
+          <a:lstStyle/>
+          <a:p>
+            <a:pPr algn="ctr"/>
+          </a:p>
+        </p:txBody>
+      </p:sp>
+      <p:sp>
+        <p:nvSpPr>
+          <p:cNvPr id="15" name="Rectangle 14"/>
+          <p:cNvSpPr/>
+          <p:nvPr/>
+        </p:nvSpPr>
+        <p:spPr>
+          <a:xfrm>
+            <a:off x="8061960" y="2423160"/>
+            <a:ext cx="3532632" cy="50292"/>
+          </a:xfrm>
+          <a:prstGeom prst="rect">
+            <a:avLst/>
+          </a:prstGeom>
+          <a:solidFill>
+            <a:srgbClr val="007C78"/>
+          </a:solidFill>
+          <a:ln>
+            <a:noFill/>
+          </a:ln>
+        </p:spPr>
+        <p:style>
+          <a:lnRef idx="1">
+            <a:schemeClr val="accent1"/>
+          </a:lnRef>
+          <a:fillRef idx="3">
+            <a:schemeClr val="accent1"/>
+          </a:fillRef>
+          <a:effectRef idx="2">
+            <a:schemeClr val="accent1"/>
+          </a:effectRef>
+          <a:fontRef idx="minor">
+            <a:schemeClr val="lt1"/>
+          </a:fontRef>
+        </p:style>
+        <p:txBody>
+          <a:bodyPr rtlCol="0" anchor="ctr"/>
+          <a:lstStyle/>
+          <a:p>
+            <a:pPr algn="ctr"/>
+          </a:p>
+        </p:txBody>
+      </p:sp>
+      <p:sp>
+        <p:nvSpPr>
+          <p:cNvPr id="16" name="TextBox 15"/>
+          <p:cNvSpPr txBox="1"/>
+          <p:nvPr/>
+        </p:nvSpPr>
+        <p:spPr>
+          <a:xfrm>
+            <a:off x="8263128" y="2606040"/>
+            <a:ext cx="3130296" cy="457200"/>
+          </a:xfrm>
+          <a:prstGeom prst="rect">
+            <a:avLst/>
+          </a:prstGeom>
+          <a:noFill/>
+        </p:spPr>
+        <p:txBody>
+          <a:bodyPr wrap="square" lIns="18288" rIns="18288" tIns="0" bIns="0">
+            <a:spAutoFit/>
+          </a:bodyPr>
+          <a:lstStyle/>
+          <a:p>
+            <a:pPr>
+              <a:spcAft>
+                <a:spcPts val="900"/>
+              </a:spcAft>
+              <a:defRPr sz="2100" b="1">
+                <a:solidFill>
+                  <a:srgbClr val="007C78"/>
+                </a:solidFill>
+                <a:latin typeface="DejaVu Sans"/>
+              </a:defRPr>
+            </a:pPr>
+            <a:r>
+              <a:t>Run new inference</a:t>
+            </a:r>
+          </a:p>
+        </p:txBody>
+      </p:sp>
+      <p:sp>
+        <p:nvSpPr>
+          <p:cNvPr id="17" name="TextBox 16"/>
+          <p:cNvSpPr txBox="1"/>
+          <p:nvPr/>
+        </p:nvSpPr>
+        <p:spPr>
+          <a:xfrm>
+            <a:off x="8263128" y="3264408"/>
+            <a:ext cx="3130296" cy="1920239"/>
+          </a:xfrm>
+          <a:prstGeom prst="rect">
+            <a:avLst/>
+          </a:prstGeom>
+          <a:noFill/>
+        </p:spPr>
+        <p:txBody>
+          <a:bodyPr wrap="square" lIns="18288" rIns="18288" tIns="0" bIns="0">
+            <a:spAutoFit/>
+          </a:bodyPr>
+          <a:lstStyle/>
+          <a:p>
+            <a:pPr>
+              <a:spcAft>
+                <a:spcPts val="900"/>
+              </a:spcAft>
+              <a:defRPr sz="1700" b="0">
+                <a:solidFill>
+                  <a:srgbClr val="132C38"/>
+                </a:solidFill>
+                <a:latin typeface="DejaVu Sans"/>
+              </a:defRPr>
+            </a:pPr>
+            <a:r>
+              <a:t>Follow the GB10 setup runbook.</a:t>
+            </a:r>
+          </a:p>
+          <a:p>
+            <a:pPr>
+              <a:spcAft>
+                <a:spcPts val="900"/>
+              </a:spcAft>
+              <a:defRPr sz="1700" b="0">
+                <a:solidFill>
+                  <a:srgbClr val="132C38"/>
+                </a:solidFill>
+                <a:latin typeface="DejaVu Sans"/>
+              </a:defRPr>
+            </a:pPr>
+            <a:r>
+              <a:t>Fetch pinned data and source.</a:t>
+            </a:r>
+          </a:p>
+          <a:p>
+            <a:pPr>
+              <a:spcAft>
+                <a:spcPts val="900"/>
+              </a:spcAft>
+              <a:defRPr sz="1700" b="0">
+                <a:solidFill>
+                  <a:srgbClr val="132C38"/>
+                </a:solidFill>
+                <a:latin typeface="DejaVu Sans"/>
+              </a:defRPr>
+            </a:pPr>
+            <a:r>
+              <a:t>Train a local classifier, then evaluate or predict.</a:t>
+            </a:r>
+          </a:p>
+        </p:txBody>
+      </p:sp>
+      <p:sp>
+        <p:nvSpPr>
+          <p:cNvPr id="18" name="Rectangle 17"/>
+          <p:cNvSpPr/>
+          <p:nvPr/>
+        </p:nvSpPr>
+        <p:spPr>
+          <a:xfrm>
+            <a:off x="594360" y="5806440"/>
+            <a:ext cx="11000232" cy="512064"/>
+          </a:xfrm>
+          <a:prstGeom prst="rect">
+            <a:avLst/>
+          </a:prstGeom>
+          <a:solidFill>
+            <a:srgbClr val="E0EAE3"/>
+          </a:solidFill>
+          <a:ln>
+            <a:noFill/>
+          </a:ln>
+        </p:spPr>
+        <p:style>
+          <a:lnRef idx="1">
+            <a:schemeClr val="accent1"/>
+          </a:lnRef>
+          <a:fillRef idx="3">
+            <a:schemeClr val="accent1"/>
+          </a:fillRef>
+          <a:effectRef idx="2">
+            <a:schemeClr val="accent1"/>
+          </a:effectRef>
+          <a:fontRef idx="minor">
+            <a:schemeClr val="lt1"/>
+          </a:fontRef>
+        </p:style>
+        <p:txBody>
+          <a:bodyPr rtlCol="0" anchor="ctr"/>
+          <a:lstStyle/>
+          <a:p>
+            <a:pPr algn="ctr"/>
+          </a:p>
+        </p:txBody>
+      </p:sp>
+      <p:sp>
+        <p:nvSpPr>
+          <p:cNvPr id="19" name="TextBox 18"/>
+          <p:cNvSpPr txBox="1"/>
+          <p:nvPr/>
+        </p:nvSpPr>
+        <p:spPr>
+          <a:xfrm>
+            <a:off x="731520" y="5897880"/>
+            <a:ext cx="10735056" cy="365760"/>
+          </a:xfrm>
+          <a:prstGeom prst="rect">
+            <a:avLst/>
+          </a:prstGeom>
+          <a:noFill/>
+        </p:spPr>
+        <p:txBody>
+          <a:bodyPr wrap="square" lIns="18288" rIns="18288" tIns="0" bIns="0">
+            <a:spAutoFit/>
+          </a:bodyPr>
+          <a:lstStyle/>
+          <a:p>
+            <a:pPr>
+              <a:spcAft>
+                <a:spcPts val="900"/>
+              </a:spcAft>
+              <a:defRPr sz="1250" b="0">
+                <a:solidFill>
+                  <a:srgbClr val="132C38"/>
+                </a:solidFill>
+                <a:latin typeface="DejaVu Sans"/>
+              </a:defRPr>
+            </a:pPr>
+            <a:r>
+              <a:t>Start at docs/customer/quickstart.md. The full GPU setup is tested on GB10, not promised for every computer.</a:t>
+            </a:r>
+          </a:p>
+        </p:txBody>
+      </p:sp>
+      <p:sp>
+        <p:nvSpPr>
+          <p:cNvPr id="20" name="TextBox 19"/>
+          <p:cNvSpPr txBox="1"/>
+          <p:nvPr/>
+        </p:nvSpPr>
+        <p:spPr>
+          <a:xfrm>
+            <a:off x="594360" y="6519672"/>
+            <a:ext cx="10424160" cy="182880"/>
+          </a:xfrm>
+          <a:prstGeom prst="rect">
+            <a:avLst/>
+          </a:prstGeom>
+          <a:noFill/>
+        </p:spPr>
+        <p:txBody>
+          <a:bodyPr wrap="square" lIns="18288" rIns="18288" tIns="0" bIns="0">
+            <a:spAutoFit/>
+          </a:bodyPr>
+          <a:lstStyle/>
+          <a:p>
+            <a:pPr>
+              <a:spcAft>
+                <a:spcPts val="900"/>
+              </a:spcAft>
+              <a:defRPr sz="900" b="0">
+                <a:solidFill>
+                  <a:srgbClr val="516774"/>
+                </a:solidFill>
+                <a:latin typeface="DejaVu Sans"/>
+              </a:defRPr>
+            </a:pPr>
+            <a:r>
+              <a:rPr>
+                <a:hlinkClick r:id="rId3"/>
+              </a:rPr>
+              <a:t>NETMAMBA+  /  MEASURED RESEARCH  /  15 September 2026</a:t>
+            </a:r>
+          </a:p>
+        </p:txBody>
+      </p:sp>
+      <p:sp>
+        <p:nvSpPr>
+          <p:cNvPr id="21" name="TextBox 20"/>
+          <p:cNvSpPr txBox="1"/>
+          <p:nvPr/>
+        </p:nvSpPr>
+        <p:spPr>
+          <a:xfrm>
+            <a:off x="11155680" y="6473952"/>
+            <a:ext cx="457200" cy="228600"/>
+          </a:xfrm>
+          <a:prstGeom prst="rect">
+            <a:avLst/>
+          </a:prstGeom>
+          <a:noFill/>
+        </p:spPr>
+        <p:txBody>
+          <a:bodyPr wrap="square" lIns="18288" rIns="18288" tIns="0" bIns="0">
+            <a:spAutoFit/>
+          </a:bodyPr>
+          <a:lstStyle/>
+          <a:p>
+            <a:pPr>
+              <a:spcAft>
+                <a:spcPts val="900"/>
+              </a:spcAft>
+              <a:defRPr sz="1100" b="0">
+                <a:solidFill>
+                  <a:srgbClr val="516774"/>
+                </a:solidFill>
+                <a:latin typeface="DejaVu Sans"/>
+              </a:defRPr>
+            </a:pPr>
+            <a:r>
+              <a:t>14</a:t>
+            </a:r>
+          </a:p>
+        </p:txBody>
+      </p:sp>
+    </p:spTree>
+  </p:cSld>
+  <p:clrMapOvr>
+    <a:masterClrMapping/>
+  </p:clrMapOvr>
+</p:sld>
+</file>
+
+<file path=ppt/slides/slide15.xml><?xml version="1.0" encoding="utf-8"?>
+<p:sld xmlns:a="http://schemas.openxmlformats.org/drawingml/2006/main" xmlns:p="http://schemas.openxmlformats.org/presentationml/2006/main" xmlns:r="http://schemas.openxmlformats.org/officeDocument/2006/relationships">
+  <p:cSld>
+    <p:spTree>
+      <p:nvGrpSpPr>
+        <p:cNvPr id="1" name=""/>
+        <p:cNvGrpSpPr/>
+        <p:nvPr/>
+      </p:nvGrpSpPr>
+      <p:grpSpPr/>
+      <p:sp>
+        <p:nvSpPr>
+          <p:cNvPr id="2" name="Rectangle 1"/>
+          <p:cNvSpPr/>
+          <p:nvPr/>
+        </p:nvSpPr>
+        <p:spPr>
+          <a:xfrm>
+            <a:off x="0" y="0"/>
+            <a:ext cx="12191999" cy="6858000"/>
+          </a:xfrm>
+          <a:prstGeom prst="rect">
+            <a:avLst/>
+          </a:prstGeom>
+          <a:solidFill>
+            <a:srgbClr val="F4F1E8"/>
+          </a:solidFill>
+          <a:ln>
+            <a:noFill/>
+          </a:ln>
+        </p:spPr>
+        <p:style>
+          <a:lnRef idx="1">
+            <a:schemeClr val="accent1"/>
+          </a:lnRef>
+          <a:fillRef idx="3">
+            <a:schemeClr val="accent1"/>
+          </a:fillRef>
+          <a:effectRef idx="2">
+            <a:schemeClr val="accent1"/>
+          </a:effectRef>
+          <a:fontRef idx="minor">
+            <a:schemeClr val="lt1"/>
+          </a:fontRef>
+        </p:style>
+        <p:txBody>
+          <a:bodyPr rtlCol="0" anchor="ctr"/>
+          <a:lstStyle/>
+          <a:p>
+            <a:pPr algn="ctr"/>
+          </a:p>
+        </p:txBody>
+      </p:sp>
+      <p:sp>
+        <p:nvSpPr>
+          <p:cNvPr id="3" name="TextBox 2"/>
+          <p:cNvSpPr txBox="1"/>
+          <p:nvPr/>
+        </p:nvSpPr>
+        <p:spPr>
+          <a:xfrm>
+            <a:off x="594360" y="338328"/>
+            <a:ext cx="10789920" cy="274320"/>
+          </a:xfrm>
+          <a:prstGeom prst="rect">
+            <a:avLst/>
+          </a:prstGeom>
+          <a:noFill/>
+        </p:spPr>
+        <p:txBody>
+          <a:bodyPr wrap="square" lIns="18288" rIns="18288" tIns="0" bIns="0">
+            <a:spAutoFit/>
+          </a:bodyPr>
+          <a:lstStyle/>
+          <a:p>
+            <a:pPr>
+              <a:spcAft>
+                <a:spcPts val="900"/>
+              </a:spcAft>
+              <a:defRPr sz="1100" b="1">
+                <a:solidFill>
+                  <a:srgbClr val="007C78"/>
+                </a:solidFill>
+                <a:latin typeface="DejaVu Sans"/>
+              </a:defRPr>
+            </a:pPr>
+            <a:r>
+              <a:t>13 / WHAT THE CHECKS PROVED</a:t>
+            </a:r>
+          </a:p>
+        </p:txBody>
+      </p:sp>
+      <p:sp>
+        <p:nvSpPr>
+          <p:cNvPr id="4" name="TextBox 3"/>
+          <p:cNvSpPr txBox="1"/>
+          <p:nvPr/>
+        </p:nvSpPr>
+        <p:spPr>
+          <a:xfrm>
+            <a:off x="594360" y="841248"/>
+            <a:ext cx="10972800" cy="621792"/>
+          </a:xfrm>
+          <a:prstGeom prst="rect">
+            <a:avLst/>
+          </a:prstGeom>
+          <a:noFill/>
+        </p:spPr>
+        <p:txBody>
+          <a:bodyPr wrap="square" lIns="18288" rIns="18288" tIns="0" bIns="0">
+            <a:spAutoFit/>
+          </a:bodyPr>
+          <a:lstStyle/>
+          <a:p>
+            <a:pPr>
+              <a:spcAft>
+                <a:spcPts val="900"/>
+              </a:spcAft>
+              <a:defRPr sz="3400" b="0">
+                <a:solidFill>
+                  <a:srgbClr val="132C38"/>
+                </a:solidFill>
+                <a:latin typeface="Liberation Serif"/>
+              </a:defRPr>
+            </a:pPr>
+            <a:r>
+              <a:t>Read a passing test in its proper scope</a:t>
+            </a:r>
+          </a:p>
+        </p:txBody>
+      </p:sp>
+      <p:sp>
+        <p:nvSpPr>
+          <p:cNvPr id="5" name="TextBox 4"/>
+          <p:cNvSpPr txBox="1"/>
+          <p:nvPr/>
+        </p:nvSpPr>
+        <p:spPr>
+          <a:xfrm>
+            <a:off x="594360" y="1600200"/>
+            <a:ext cx="10881360" cy="548640"/>
+          </a:xfrm>
+          <a:prstGeom prst="rect">
+            <a:avLst/>
+          </a:prstGeom>
+          <a:noFill/>
+        </p:spPr>
+        <p:txBody>
+          <a:bodyPr wrap="square" lIns="18288" rIns="18288" tIns="0" bIns="0">
+            <a:spAutoFit/>
+          </a:bodyPr>
+          <a:lstStyle/>
+          <a:p>
+            <a:pPr>
+              <a:spcAft>
+                <a:spcPts val="900"/>
+              </a:spcAft>
+              <a:defRPr sz="1600" b="0">
+                <a:solidFill>
+                  <a:srgbClr val="516774"/>
+                </a:solidFill>
+                <a:latin typeface="DejaVu Sans"/>
+              </a:defRPr>
+            </a:pPr>
+            <a:r>
+              <a:t>Passing software checks and successful GPU runs answer different questions.</a:t>
+            </a:r>
+          </a:p>
+        </p:txBody>
+      </p:sp>
+      <p:sp>
+        <p:nvSpPr>
+          <p:cNvPr id="6" name="Rectangle 5"/>
+          <p:cNvSpPr/>
+          <p:nvPr/>
+        </p:nvSpPr>
+        <p:spPr>
+          <a:xfrm>
+            <a:off x="594360" y="2423160"/>
+            <a:ext cx="3532632" cy="2880360"/>
+          </a:xfrm>
+          <a:prstGeom prst="rect">
+            <a:avLst/>
+          </a:prstGeom>
+          <a:solidFill>
+            <a:srgbClr val="FFFFFF"/>
+          </a:solidFill>
+          <a:ln>
+            <a:noFill/>
+          </a:ln>
+        </p:spPr>
+        <p:style>
+          <a:lnRef idx="1">
+            <a:schemeClr val="accent1"/>
+          </a:lnRef>
+          <a:fillRef idx="3">
+            <a:schemeClr val="accent1"/>
+          </a:fillRef>
+          <a:effectRef idx="2">
+            <a:schemeClr val="accent1"/>
+          </a:effectRef>
+          <a:fontRef idx="minor">
+            <a:schemeClr val="lt1"/>
+          </a:fontRef>
+        </p:style>
+        <p:txBody>
+          <a:bodyPr rtlCol="0" anchor="ctr"/>
+          <a:lstStyle/>
+          <a:p>
+            <a:pPr algn="ctr"/>
+          </a:p>
+        </p:txBody>
+      </p:sp>
+      <p:sp>
+        <p:nvSpPr>
+          <p:cNvPr id="7" name="Rectangle 6"/>
+          <p:cNvSpPr/>
+          <p:nvPr/>
+        </p:nvSpPr>
+        <p:spPr>
+          <a:xfrm>
+            <a:off x="594360" y="2423160"/>
+            <a:ext cx="3532632" cy="50292"/>
+          </a:xfrm>
+          <a:prstGeom prst="rect">
+            <a:avLst/>
+          </a:prstGeom>
+          <a:solidFill>
+            <a:srgbClr val="007C78"/>
+          </a:solidFill>
+          <a:ln>
+            <a:noFill/>
+          </a:ln>
+        </p:spPr>
+        <p:style>
+          <a:lnRef idx="1">
+            <a:schemeClr val="accent1"/>
+          </a:lnRef>
+          <a:fillRef idx="3">
+            <a:schemeClr val="accent1"/>
+          </a:fillRef>
+          <a:effectRef idx="2">
+            <a:schemeClr val="accent1"/>
+          </a:effectRef>
+          <a:fontRef idx="minor">
+            <a:schemeClr val="lt1"/>
+          </a:fontRef>
+        </p:style>
+        <p:txBody>
+          <a:bodyPr rtlCol="0" anchor="ctr"/>
+          <a:lstStyle/>
+          <a:p>
+            <a:pPr algn="ctr"/>
+          </a:p>
+        </p:txBody>
+      </p:sp>
+      <p:sp>
+        <p:nvSpPr>
+          <p:cNvPr id="8" name="TextBox 7"/>
+          <p:cNvSpPr txBox="1"/>
+          <p:nvPr/>
+        </p:nvSpPr>
+        <p:spPr>
+          <a:xfrm>
+            <a:off x="795528" y="2606040"/>
+            <a:ext cx="3130296" cy="457200"/>
+          </a:xfrm>
+          <a:prstGeom prst="rect">
+            <a:avLst/>
+          </a:prstGeom>
+          <a:noFill/>
+        </p:spPr>
+        <p:txBody>
+          <a:bodyPr wrap="square" lIns="18288" rIns="18288" tIns="0" bIns="0">
+            <a:spAutoFit/>
+          </a:bodyPr>
+          <a:lstStyle/>
+          <a:p>
+            <a:pPr>
+              <a:spcAft>
+                <a:spcPts val="900"/>
+              </a:spcAft>
+              <a:defRPr sz="2100" b="1">
+                <a:solidFill>
+                  <a:srgbClr val="007C78"/>
+                </a:solidFill>
+                <a:latin typeface="DejaVu Sans"/>
+              </a:defRPr>
+            </a:pPr>
+            <a:r>
+              <a:t>CPU checks</a:t>
+            </a:r>
+          </a:p>
+        </p:txBody>
+      </p:sp>
+      <p:sp>
+        <p:nvSpPr>
+          <p:cNvPr id="9" name="TextBox 8"/>
+          <p:cNvSpPr txBox="1"/>
+          <p:nvPr/>
+        </p:nvSpPr>
+        <p:spPr>
+          <a:xfrm>
+            <a:off x="795528" y="3264408"/>
+            <a:ext cx="3130296" cy="1920239"/>
+          </a:xfrm>
+          <a:prstGeom prst="rect">
+            <a:avLst/>
+          </a:prstGeom>
+          <a:noFill/>
+        </p:spPr>
+        <p:txBody>
+          <a:bodyPr wrap="square" lIns="18288" rIns="18288" tIns="0" bIns="0">
+            <a:spAutoFit/>
+          </a:bodyPr>
+          <a:lstStyle/>
+          <a:p>
+            <a:pPr>
+              <a:spcAft>
+                <a:spcPts val="900"/>
+              </a:spcAft>
+              <a:defRPr sz="1700" b="0">
+                <a:solidFill>
+                  <a:srgbClr val="132C38"/>
+                </a:solidFill>
+                <a:latin typeface="DejaVu Sans"/>
+              </a:defRPr>
+            </a:pPr>
+            <a:r>
+              <a:t>54 tests passed.</a:t>
+            </a:r>
+          </a:p>
+          <a:p>
+            <a:pPr>
+              <a:spcAft>
+                <a:spcPts val="900"/>
+              </a:spcAft>
+              <a:defRPr sz="1700" b="0">
+                <a:solidFill>
+                  <a:srgbClr val="132C38"/>
+                </a:solidFill>
+                <a:latin typeface="DejaVu Sans"/>
+              </a:defRPr>
+            </a:pPr>
+            <a:r>
+              <a:t>Saved metrics, hashes, links and document alignment checked.</a:t>
+            </a:r>
+          </a:p>
+          <a:p>
+            <a:pPr>
+              <a:spcAft>
+                <a:spcPts val="900"/>
+              </a:spcAft>
+              <a:defRPr sz="1700" b="0">
+                <a:solidFill>
+                  <a:srgbClr val="132C38"/>
+                </a:solidFill>
+                <a:latin typeface="DejaVu Sans"/>
+              </a:defRPr>
+            </a:pPr>
+            <a:r>
+              <a:t>Prior package CI passed on Python 3.10 and 3.12.</a:t>
+            </a:r>
+          </a:p>
+        </p:txBody>
+      </p:sp>
+      <p:sp>
+        <p:nvSpPr>
+          <p:cNvPr id="10" name="Rectangle 9"/>
+          <p:cNvSpPr/>
+          <p:nvPr/>
+        </p:nvSpPr>
+        <p:spPr>
+          <a:xfrm>
+            <a:off x="4328160" y="2423160"/>
+            <a:ext cx="3532632" cy="2880360"/>
+          </a:xfrm>
+          <a:prstGeom prst="rect">
+            <a:avLst/>
+          </a:prstGeom>
+          <a:solidFill>
+            <a:srgbClr val="FFFFFF"/>
+          </a:solidFill>
+          <a:ln>
+            <a:noFill/>
+          </a:ln>
+        </p:spPr>
+        <p:style>
+          <a:lnRef idx="1">
+            <a:schemeClr val="accent1"/>
+          </a:lnRef>
+          <a:fillRef idx="3">
+            <a:schemeClr val="accent1"/>
+          </a:fillRef>
+          <a:effectRef idx="2">
+            <a:schemeClr val="accent1"/>
+          </a:effectRef>
+          <a:fontRef idx="minor">
+            <a:schemeClr val="lt1"/>
+          </a:fontRef>
+        </p:style>
+        <p:txBody>
+          <a:bodyPr rtlCol="0" anchor="ctr"/>
+          <a:lstStyle/>
+          <a:p>
+            <a:pPr algn="ctr"/>
+          </a:p>
+        </p:txBody>
+      </p:sp>
+      <p:sp>
+        <p:nvSpPr>
+          <p:cNvPr id="11" name="Rectangle 10"/>
+          <p:cNvSpPr/>
+          <p:nvPr/>
+        </p:nvSpPr>
+        <p:spPr>
+          <a:xfrm>
+            <a:off x="4328160" y="2423160"/>
+            <a:ext cx="3532632" cy="50292"/>
+          </a:xfrm>
+          <a:prstGeom prst="rect">
+            <a:avLst/>
+          </a:prstGeom>
+          <a:solidFill>
+            <a:srgbClr val="007C78"/>
+          </a:solidFill>
+          <a:ln>
+            <a:noFill/>
+          </a:ln>
+        </p:spPr>
+        <p:style>
+          <a:lnRef idx="1">
+            <a:schemeClr val="accent1"/>
+          </a:lnRef>
+          <a:fillRef idx="3">
+            <a:schemeClr val="accent1"/>
+          </a:fillRef>
+          <a:effectRef idx="2">
+            <a:schemeClr val="accent1"/>
+          </a:effectRef>
+          <a:fontRef idx="minor">
+            <a:schemeClr val="lt1"/>
+          </a:fontRef>
+        </p:style>
+        <p:txBody>
+          <a:bodyPr rtlCol="0" anchor="ctr"/>
+          <a:lstStyle/>
+          <a:p>
+            <a:pPr algn="ctr"/>
+          </a:p>
+        </p:txBody>
+      </p:sp>
+      <p:sp>
+        <p:nvSpPr>
+          <p:cNvPr id="12" name="TextBox 11"/>
+          <p:cNvSpPr txBox="1"/>
+          <p:nvPr/>
+        </p:nvSpPr>
+        <p:spPr>
+          <a:xfrm>
+            <a:off x="4529328" y="2606040"/>
+            <a:ext cx="3130296" cy="457200"/>
+          </a:xfrm>
+          <a:prstGeom prst="rect">
+            <a:avLst/>
+          </a:prstGeom>
+          <a:noFill/>
+        </p:spPr>
+        <p:txBody>
+          <a:bodyPr wrap="square" lIns="18288" rIns="18288" tIns="0" bIns="0">
+            <a:spAutoFit/>
+          </a:bodyPr>
+          <a:lstStyle/>
+          <a:p>
+            <a:pPr>
+              <a:spcAft>
+                <a:spcPts val="900"/>
+              </a:spcAft>
+              <a:defRPr sz="2100" b="1">
+                <a:solidFill>
+                  <a:srgbClr val="007C78"/>
+                </a:solidFill>
+                <a:latin typeface="DejaVu Sans"/>
+              </a:defRPr>
+            </a:pPr>
+            <a:r>
+              <a:t>Fresh GPU checks</a:t>
+            </a:r>
+          </a:p>
+        </p:txBody>
+      </p:sp>
+      <p:sp>
+        <p:nvSpPr>
+          <p:cNvPr id="13" name="TextBox 12"/>
+          <p:cNvSpPr txBox="1"/>
+          <p:nvPr/>
+        </p:nvSpPr>
+        <p:spPr>
+          <a:xfrm>
+            <a:off x="4529328" y="3264408"/>
+            <a:ext cx="3130296" cy="1920239"/>
+          </a:xfrm>
+          <a:prstGeom prst="rect">
+            <a:avLst/>
+          </a:prstGeom>
+          <a:noFill/>
+        </p:spPr>
+        <p:txBody>
+          <a:bodyPr wrap="square" lIns="18288" rIns="18288" tIns="0" bIns="0">
+            <a:spAutoFit/>
+          </a:bodyPr>
+          <a:lstStyle/>
+          <a:p>
+            <a:pPr>
+              <a:spcAft>
+                <a:spcPts val="900"/>
+              </a:spcAft>
+              <a:defRPr sz="1700" b="0">
+                <a:solidFill>
+                  <a:srgbClr val="132C38"/>
+                </a:solidFill>
+                <a:latin typeface="DejaVu Sans"/>
+              </a:defRPr>
+            </a:pPr>
+            <a:r>
+              <a:t>All three model-only exports reproduced their scores.</a:t>
+            </a:r>
+          </a:p>
+          <a:p>
+            <a:pPr>
+              <a:spcAft>
+                <a:spcPts val="900"/>
+              </a:spcAft>
+              <a:defRPr sz="1700" b="0">
+                <a:solidFill>
+                  <a:srgbClr val="132C38"/>
+                </a:solidFill>
+                <a:latin typeface="DejaVu Sans"/>
+              </a:defRPr>
+            </a:pPr>
+            <a:r>
+              <a:t>Unlabeled inference matched all 1,041 seed-0 predictions in this run.</a:t>
+            </a:r>
+          </a:p>
+        </p:txBody>
+      </p:sp>
+      <p:sp>
+        <p:nvSpPr>
+          <p:cNvPr id="14" name="Rectangle 13"/>
+          <p:cNvSpPr/>
+          <p:nvPr/>
+        </p:nvSpPr>
+        <p:spPr>
+          <a:xfrm>
+            <a:off x="8061960" y="2423160"/>
+            <a:ext cx="3532632" cy="2880360"/>
+          </a:xfrm>
+          <a:prstGeom prst="rect">
+            <a:avLst/>
+          </a:prstGeom>
+          <a:solidFill>
+            <a:srgbClr val="FFFFFF"/>
+          </a:solidFill>
+          <a:ln>
+            <a:noFill/>
+          </a:ln>
+        </p:spPr>
+        <p:style>
+          <a:lnRef idx="1">
+            <a:schemeClr val="accent1"/>
+          </a:lnRef>
+          <a:fillRef idx="3">
+            <a:schemeClr val="accent1"/>
+          </a:fillRef>
+          <a:effectRef idx="2">
+            <a:schemeClr val="accent1"/>
+          </a:effectRef>
+          <a:fontRef idx="minor">
+            <a:schemeClr val="lt1"/>
+          </a:fontRef>
+        </p:style>
+        <p:txBody>
+          <a:bodyPr rtlCol="0" anchor="ctr"/>
+          <a:lstStyle/>
+          <a:p>
+            <a:pPr algn="ctr"/>
+          </a:p>
+        </p:txBody>
+      </p:sp>
+      <p:sp>
+        <p:nvSpPr>
+          <p:cNvPr id="15" name="Rectangle 14"/>
+          <p:cNvSpPr/>
+          <p:nvPr/>
+        </p:nvSpPr>
+        <p:spPr>
+          <a:xfrm>
+            <a:off x="8061960" y="2423160"/>
+            <a:ext cx="3532632" cy="50292"/>
+          </a:xfrm>
+          <a:prstGeom prst="rect">
+            <a:avLst/>
+          </a:prstGeom>
+          <a:solidFill>
+            <a:srgbClr val="007C78"/>
+          </a:solidFill>
+          <a:ln>
+            <a:noFill/>
+          </a:ln>
+        </p:spPr>
+        <p:style>
+          <a:lnRef idx="1">
+            <a:schemeClr val="accent1"/>
+          </a:lnRef>
+          <a:fillRef idx="3">
+            <a:schemeClr val="accent1"/>
+          </a:fillRef>
+          <a:effectRef idx="2">
+            <a:schemeClr val="accent1"/>
+          </a:effectRef>
+          <a:fontRef idx="minor">
+            <a:schemeClr val="lt1"/>
+          </a:fontRef>
+        </p:style>
+        <p:txBody>
+          <a:bodyPr rtlCol="0" anchor="ctr"/>
+          <a:lstStyle/>
+          <a:p>
+            <a:pPr algn="ctr"/>
+          </a:p>
+        </p:txBody>
+      </p:sp>
+      <p:sp>
+        <p:nvSpPr>
+          <p:cNvPr id="16" name="TextBox 15"/>
+          <p:cNvSpPr txBox="1"/>
+          <p:nvPr/>
+        </p:nvSpPr>
+        <p:spPr>
+          <a:xfrm>
+            <a:off x="8263128" y="2606040"/>
+            <a:ext cx="3130296" cy="457200"/>
+          </a:xfrm>
+          <a:prstGeom prst="rect">
+            <a:avLst/>
+          </a:prstGeom>
+          <a:noFill/>
+        </p:spPr>
+        <p:txBody>
+          <a:bodyPr wrap="square" lIns="18288" rIns="18288" tIns="0" bIns="0">
+            <a:spAutoFit/>
+          </a:bodyPr>
+          <a:lstStyle/>
+          <a:p>
+            <a:pPr>
+              <a:spcAft>
+                <a:spcPts val="900"/>
+              </a:spcAft>
+              <a:defRPr sz="2100" b="1">
+                <a:solidFill>
+                  <a:srgbClr val="007C78"/>
+                </a:solidFill>
+                <a:latin typeface="DejaVu Sans"/>
+              </a:defRPr>
+            </a:pPr>
+            <a:r>
+              <a:t>Known limit</a:t>
+            </a:r>
+          </a:p>
+        </p:txBody>
+      </p:sp>
+      <p:sp>
+        <p:nvSpPr>
+          <p:cNvPr id="17" name="TextBox 16"/>
+          <p:cNvSpPr txBox="1"/>
+          <p:nvPr/>
+        </p:nvSpPr>
+        <p:spPr>
+          <a:xfrm>
+            <a:off x="8263128" y="3264408"/>
+            <a:ext cx="3130296" cy="1920239"/>
+          </a:xfrm>
+          <a:prstGeom prst="rect">
+            <a:avLst/>
+          </a:prstGeom>
+          <a:noFill/>
+        </p:spPr>
+        <p:txBody>
+          <a:bodyPr wrap="square" lIns="18288" rIns="18288" tIns="0" bIns="0">
+            <a:spAutoFit/>
+          </a:bodyPr>
+          <a:lstStyle/>
+          <a:p>
+            <a:pPr>
+              <a:spcAft>
+                <a:spcPts val="900"/>
+              </a:spcAft>
+              <a:defRPr sz="1700" b="0">
+                <a:solidFill>
+                  <a:srgbClr val="132C38"/>
+                </a:solidFill>
+                <a:latin typeface="DejaVu Sans"/>
+              </a:defRPr>
+            </a:pPr>
+            <a:r>
+              <a:t>GPU inference works.</a:t>
+            </a:r>
+          </a:p>
+          <a:p>
+            <a:pPr>
+              <a:spcAft>
+                <a:spcPts val="900"/>
+              </a:spcAft>
+              <a:defRPr sz="1700" b="0">
+                <a:solidFill>
+                  <a:srgbClr val="132C38"/>
+                </a:solidFill>
+                <a:latin typeface="DejaVu Sans"/>
+              </a:defRPr>
+            </a:pPr>
+            <a:r>
+              <a:t>The tested Torch export path cannot trace a custom CUDA operation.</a:t>
+            </a:r>
+          </a:p>
+          <a:p>
+            <a:pPr>
+              <a:spcAft>
+                <a:spcPts val="900"/>
+              </a:spcAft>
+              <a:defRPr sz="1700" b="0">
+                <a:solidFill>
+                  <a:srgbClr val="132C38"/>
+                </a:solidFill>
+                <a:latin typeface="DejaVu Sans"/>
+              </a:defRPr>
+            </a:pPr>
+            <a:r>
+              <a:t>No NPU or live IDS test has passed.</a:t>
+            </a:r>
+          </a:p>
+        </p:txBody>
+      </p:sp>
+      <p:sp>
+        <p:nvSpPr>
+          <p:cNvPr id="18" name="Rectangle 17"/>
+          <p:cNvSpPr/>
+          <p:nvPr/>
+        </p:nvSpPr>
+        <p:spPr>
+          <a:xfrm>
+            <a:off x="594360" y="5806440"/>
+            <a:ext cx="11000232" cy="512064"/>
+          </a:xfrm>
+          <a:prstGeom prst="rect">
+            <a:avLst/>
+          </a:prstGeom>
+          <a:solidFill>
+            <a:srgbClr val="E0EAE3"/>
+          </a:solidFill>
+          <a:ln>
+            <a:noFill/>
+          </a:ln>
+        </p:spPr>
+        <p:style>
+          <a:lnRef idx="1">
+            <a:schemeClr val="accent1"/>
+          </a:lnRef>
+          <a:fillRef idx="3">
+            <a:schemeClr val="accent1"/>
+          </a:fillRef>
+          <a:effectRef idx="2">
+            <a:schemeClr val="accent1"/>
+          </a:effectRef>
+          <a:fontRef idx="minor">
+            <a:schemeClr val="lt1"/>
+          </a:fontRef>
+        </p:style>
+        <p:txBody>
+          <a:bodyPr rtlCol="0" anchor="ctr"/>
+          <a:lstStyle/>
+          <a:p>
+            <a:pPr algn="ctr"/>
+          </a:p>
+        </p:txBody>
+      </p:sp>
+      <p:sp>
+        <p:nvSpPr>
+          <p:cNvPr id="19" name="TextBox 18"/>
+          <p:cNvSpPr txBox="1"/>
+          <p:nvPr/>
+        </p:nvSpPr>
+        <p:spPr>
+          <a:xfrm>
+            <a:off x="731520" y="5897880"/>
+            <a:ext cx="10735056" cy="365760"/>
+          </a:xfrm>
+          <a:prstGeom prst="rect">
+            <a:avLst/>
+          </a:prstGeom>
+          <a:noFill/>
+        </p:spPr>
+        <p:txBody>
+          <a:bodyPr wrap="square" lIns="18288" rIns="18288" tIns="0" bIns="0">
+            <a:spAutoFit/>
+          </a:bodyPr>
+          <a:lstStyle/>
+          <a:p>
+            <a:pPr>
+              <a:spcAft>
+                <a:spcPts val="900"/>
+              </a:spcAft>
+              <a:defRPr sz="1250" b="0">
+                <a:solidFill>
+                  <a:srgbClr val="132C38"/>
+                </a:solidFill>
+                <a:latin typeface="DejaVu Sans"/>
+              </a:defRPr>
+            </a:pPr>
+            <a:r>
+              <a:t>See verification.md for dated evidence and quickstart.md for commands. A passing CPU test does not rerun GPU training.</a:t>
+            </a:r>
+          </a:p>
+        </p:txBody>
+      </p:sp>
+      <p:sp>
+        <p:nvSpPr>
+          <p:cNvPr id="20" name="TextBox 19"/>
+          <p:cNvSpPr txBox="1"/>
+          <p:nvPr/>
+        </p:nvSpPr>
+        <p:spPr>
+          <a:xfrm>
+            <a:off x="594360" y="6519672"/>
+            <a:ext cx="10424160" cy="182880"/>
+          </a:xfrm>
+          <a:prstGeom prst="rect">
+            <a:avLst/>
+          </a:prstGeom>
+          <a:noFill/>
+        </p:spPr>
+        <p:txBody>
+          <a:bodyPr wrap="square" lIns="18288" rIns="18288" tIns="0" bIns="0">
+            <a:spAutoFit/>
+          </a:bodyPr>
+          <a:lstStyle/>
+          <a:p>
+            <a:pPr>
+              <a:spcAft>
+                <a:spcPts val="900"/>
+              </a:spcAft>
+              <a:defRPr sz="900" b="0">
+                <a:solidFill>
+                  <a:srgbClr val="516774"/>
+                </a:solidFill>
+                <a:latin typeface="DejaVu Sans"/>
+              </a:defRPr>
+            </a:pPr>
+            <a:r>
+              <a:rPr>
+                <a:hlinkClick r:id="rId3"/>
+              </a:rPr>
+              <a:t>NETMAMBA+  /  MEASURED RESEARCH  /  15 September 2026</a:t>
+            </a:r>
+          </a:p>
+        </p:txBody>
+      </p:sp>
+      <p:sp>
+        <p:nvSpPr>
+          <p:cNvPr id="21" name="TextBox 20"/>
+          <p:cNvSpPr txBox="1"/>
+          <p:nvPr/>
+        </p:nvSpPr>
+        <p:spPr>
+          <a:xfrm>
+            <a:off x="11155680" y="6473952"/>
+            <a:ext cx="457200" cy="228600"/>
+          </a:xfrm>
+          <a:prstGeom prst="rect">
+            <a:avLst/>
+          </a:prstGeom>
+          <a:noFill/>
+        </p:spPr>
+        <p:txBody>
+          <a:bodyPr wrap="square" lIns="18288" rIns="18288" tIns="0" bIns="0">
+            <a:spAutoFit/>
+          </a:bodyPr>
+          <a:lstStyle/>
+          <a:p>
+            <a:pPr>
+              <a:spcAft>
+                <a:spcPts val="900"/>
+              </a:spcAft>
+              <a:defRPr sz="1100" b="0">
+                <a:solidFill>
+                  <a:srgbClr val="516774"/>
+                </a:solidFill>
+                <a:latin typeface="DejaVu Sans"/>
+              </a:defRPr>
+            </a:pPr>
+            <a:r>
+              <a:t>15</a:t>
+            </a:r>
+          </a:p>
+        </p:txBody>
+      </p:sp>
+    </p:spTree>
+  </p:cSld>
+  <p:clrMapOvr>
+    <a:masterClrMapping/>
+  </p:clrMapOvr>
+</p:sld>
+</file>
+
+<file path=ppt/slides/slide16.xml><?xml version="1.0" encoding="utf-8"?>
+<p:sld xmlns:a="http://schemas.openxmlformats.org/drawingml/2006/main" xmlns:p="http://schemas.openxmlformats.org/presentationml/2006/main" xmlns:r="http://schemas.openxmlformats.org/officeDocument/2006/relationships">
+  <p:cSld>
+    <p:spTree>
+      <p:nvGrpSpPr>
+        <p:cNvPr id="1" name=""/>
+        <p:cNvGrpSpPr/>
+        <p:nvPr/>
+      </p:nvGrpSpPr>
+      <p:grpSpPr/>
+      <p:sp>
+        <p:nvSpPr>
+          <p:cNvPr id="2" name="Rectangle 1"/>
+          <p:cNvSpPr/>
+          <p:nvPr/>
+        </p:nvSpPr>
+        <p:spPr>
+          <a:xfrm>
+            <a:off x="0" y="0"/>
+            <a:ext cx="12191999" cy="6858000"/>
+          </a:xfrm>
+          <a:prstGeom prst="rect">
+            <a:avLst/>
+          </a:prstGeom>
+          <a:solidFill>
+            <a:srgbClr val="F4F1E8"/>
+          </a:solidFill>
+          <a:ln>
+            <a:noFill/>
+          </a:ln>
+        </p:spPr>
+        <p:style>
+          <a:lnRef idx="1">
+            <a:schemeClr val="accent1"/>
+          </a:lnRef>
+          <a:fillRef idx="3">
+            <a:schemeClr val="accent1"/>
+          </a:fillRef>
+          <a:effectRef idx="2">
+            <a:schemeClr val="accent1"/>
+          </a:effectRef>
+          <a:fontRef idx="minor">
+            <a:schemeClr val="lt1"/>
+          </a:fontRef>
+        </p:style>
+        <p:txBody>
+          <a:bodyPr rtlCol="0" anchor="ctr"/>
+          <a:lstStyle/>
+          <a:p>
+            <a:pPr algn="ctr"/>
+          </a:p>
+        </p:txBody>
+      </p:sp>
+      <p:sp>
+        <p:nvSpPr>
+          <p:cNvPr id="3" name="TextBox 2"/>
+          <p:cNvSpPr txBox="1"/>
+          <p:nvPr/>
+        </p:nvSpPr>
+        <p:spPr>
+          <a:xfrm>
+            <a:off x="594360" y="338328"/>
+            <a:ext cx="10789920" cy="274320"/>
+          </a:xfrm>
+          <a:prstGeom prst="rect">
+            <a:avLst/>
+          </a:prstGeom>
+          <a:noFill/>
+        </p:spPr>
+        <p:txBody>
+          <a:bodyPr wrap="square" lIns="18288" rIns="18288" tIns="0" bIns="0">
+            <a:spAutoFit/>
+          </a:bodyPr>
+          <a:lstStyle/>
+          <a:p>
+            <a:pPr>
+              <a:spcAft>
+                <a:spcPts val="900"/>
+              </a:spcAft>
+              <a:defRPr sz="1100" b="1">
+                <a:solidFill>
+                  <a:srgbClr val="007C78"/>
+                </a:solidFill>
+                <a:latin typeface="DejaVu Sans"/>
+              </a:defRPr>
+            </a:pPr>
+            <a:r>
+              <a:t>APPENDIX / WHERE TO VERIFY IT</a:t>
+            </a:r>
+          </a:p>
+        </p:txBody>
+      </p:sp>
+      <p:sp>
+        <p:nvSpPr>
+          <p:cNvPr id="4" name="TextBox 3"/>
+          <p:cNvSpPr txBox="1"/>
+          <p:nvPr/>
+        </p:nvSpPr>
+        <p:spPr>
+          <a:xfrm>
+            <a:off x="594360" y="841248"/>
+            <a:ext cx="10972800" cy="621792"/>
+          </a:xfrm>
+          <a:prstGeom prst="rect">
+            <a:avLst/>
+          </a:prstGeom>
+          <a:noFill/>
+        </p:spPr>
+        <p:txBody>
+          <a:bodyPr wrap="square" lIns="18288" rIns="18288" tIns="0" bIns="0">
+            <a:spAutoFit/>
+          </a:bodyPr>
+          <a:lstStyle/>
+          <a:p>
+            <a:pPr>
+              <a:spcAft>
+                <a:spcPts val="900"/>
+              </a:spcAft>
+              <a:defRPr sz="3400" b="0">
+                <a:solidFill>
+                  <a:srgbClr val="132C38"/>
+                </a:solidFill>
+                <a:latin typeface="Liberation Serif"/>
+              </a:defRPr>
+            </a:pPr>
+            <a:r>
+              <a:t>Every measured claim has a saved artifact</a:t>
+            </a:r>
+          </a:p>
+        </p:txBody>
+      </p:sp>
+      <p:sp>
+        <p:nvSpPr>
+          <p:cNvPr id="5" name="TextBox 4"/>
+          <p:cNvSpPr txBox="1"/>
+          <p:nvPr/>
+        </p:nvSpPr>
+        <p:spPr>
+          <a:xfrm>
+            <a:off x="594360" y="1600200"/>
+            <a:ext cx="10881360" cy="548640"/>
+          </a:xfrm>
+          <a:prstGeom prst="rect">
+            <a:avLst/>
+          </a:prstGeom>
+          <a:noFill/>
+        </p:spPr>
+        <p:txBody>
+          <a:bodyPr wrap="square" lIns="18288" rIns="18288" tIns="0" bIns="0">
+            <a:spAutoFit/>
+          </a:bodyPr>
+          <a:lstStyle/>
+          <a:p>
+            <a:pPr>
+              <a:spcAft>
+                <a:spcPts val="900"/>
+              </a:spcAft>
+              <a:defRPr sz="1600" b="0">
+                <a:solidFill>
+                  <a:srgbClr val="516774"/>
+                </a:solidFill>
+                <a:latin typeface="DejaVu Sans"/>
+              </a:defRPr>
+            </a:pPr>
+            <a:r>
+              <a:t>The repository is the handoff: explanation, editable files, commands and reviewed evidence.</a:t>
+            </a:r>
+          </a:p>
+        </p:txBody>
+      </p:sp>
+      <p:sp>
+        <p:nvSpPr>
+          <p:cNvPr id="6" name="Rectangle 5"/>
+          <p:cNvSpPr/>
+          <p:nvPr/>
+        </p:nvSpPr>
+        <p:spPr>
+          <a:xfrm>
+            <a:off x="594360" y="2423160"/>
+            <a:ext cx="3532632" cy="2880360"/>
+          </a:xfrm>
+          <a:prstGeom prst="rect">
+            <a:avLst/>
+          </a:prstGeom>
+          <a:solidFill>
+            <a:srgbClr val="FFFFFF"/>
+          </a:solidFill>
+          <a:ln>
+            <a:noFill/>
+          </a:ln>
+        </p:spPr>
+        <p:style>
+          <a:lnRef idx="1">
+            <a:schemeClr val="accent1"/>
+          </a:lnRef>
+          <a:fillRef idx="3">
+            <a:schemeClr val="accent1"/>
+          </a:fillRef>
+          <a:effectRef idx="2">
+            <a:schemeClr val="accent1"/>
+          </a:effectRef>
+          <a:fontRef idx="minor">
+            <a:schemeClr val="lt1"/>
+          </a:fontRef>
+        </p:style>
+        <p:txBody>
+          <a:bodyPr rtlCol="0" anchor="ctr"/>
+          <a:lstStyle/>
+          <a:p>
+            <a:pPr algn="ctr"/>
+          </a:p>
+        </p:txBody>
+      </p:sp>
+      <p:sp>
+        <p:nvSpPr>
+          <p:cNvPr id="7" name="Rectangle 6"/>
+          <p:cNvSpPr/>
+          <p:nvPr/>
+        </p:nvSpPr>
+        <p:spPr>
+          <a:xfrm>
+            <a:off x="594360" y="2423160"/>
+            <a:ext cx="3532632" cy="50292"/>
+          </a:xfrm>
+          <a:prstGeom prst="rect">
+            <a:avLst/>
+          </a:prstGeom>
+          <a:solidFill>
+            <a:srgbClr val="007C78"/>
+          </a:solidFill>
+          <a:ln>
+            <a:noFill/>
+          </a:ln>
+        </p:spPr>
+        <p:style>
+          <a:lnRef idx="1">
+            <a:schemeClr val="accent1"/>
+          </a:lnRef>
+          <a:fillRef idx="3">
+            <a:schemeClr val="accent1"/>
+          </a:fillRef>
+          <a:effectRef idx="2">
+            <a:schemeClr val="accent1"/>
+          </a:effectRef>
+          <a:fontRef idx="minor">
+            <a:schemeClr val="lt1"/>
+          </a:fontRef>
+        </p:style>
+        <p:txBody>
+          <a:bodyPr rtlCol="0" anchor="ctr"/>
+          <a:lstStyle/>
+          <a:p>
+            <a:pPr algn="ctr"/>
+          </a:p>
+        </p:txBody>
+      </p:sp>
+      <p:sp>
+        <p:nvSpPr>
+          <p:cNvPr id="8" name="TextBox 7"/>
+          <p:cNvSpPr txBox="1"/>
+          <p:nvPr/>
+        </p:nvSpPr>
+        <p:spPr>
+          <a:xfrm>
+            <a:off x="795528" y="2606040"/>
+            <a:ext cx="3130296" cy="457200"/>
+          </a:xfrm>
+          <a:prstGeom prst="rect">
+            <a:avLst/>
+          </a:prstGeom>
+          <a:noFill/>
+        </p:spPr>
+        <p:txBody>
+          <a:bodyPr wrap="square" lIns="18288" rIns="18288" tIns="0" bIns="0">
+            <a:spAutoFit/>
+          </a:bodyPr>
+          <a:lstStyle/>
+          <a:p>
+            <a:pPr>
+              <a:spcAft>
+                <a:spcPts val="900"/>
+              </a:spcAft>
+              <a:defRPr sz="2100" b="1">
+                <a:solidFill>
+                  <a:srgbClr val="007C78"/>
+                </a:solidFill>
+                <a:latin typeface="DejaVu Sans"/>
+              </a:defRPr>
+            </a:pPr>
+            <a:r>
+              <a:t>Start here</a:t>
+            </a:r>
+          </a:p>
+        </p:txBody>
+      </p:sp>
+      <p:sp>
+        <p:nvSpPr>
+          <p:cNvPr id="9" name="TextBox 8"/>
+          <p:cNvSpPr txBox="1"/>
+          <p:nvPr/>
+        </p:nvSpPr>
+        <p:spPr>
+          <a:xfrm>
+            <a:off x="795528" y="3264408"/>
+            <a:ext cx="3130296" cy="1920239"/>
+          </a:xfrm>
+          <a:prstGeom prst="rect">
+            <a:avLst/>
+          </a:prstGeom>
+          <a:noFill/>
+        </p:spPr>
+        <p:txBody>
+          <a:bodyPr wrap="square" lIns="18288" rIns="18288" tIns="0" bIns="0">
+            <a:spAutoFit/>
+          </a:bodyPr>
+          <a:lstStyle/>
+          <a:p>
+            <a:pPr>
+              <a:spcAft>
+                <a:spcPts val="900"/>
+              </a:spcAft>
+              <a:defRPr sz="1600" b="0">
+                <a:solidFill>
+                  <a:srgbClr val="132C38"/>
+                </a:solidFill>
+                <a:latin typeface="DejaVu Sans"/>
+              </a:defRPr>
+            </a:pPr>
+            <a:r>
+              <a:t>docs/customer/README.md</a:t>
+            </a:r>
+          </a:p>
+          <a:p>
+            <a:pPr>
+              <a:spcAft>
+                <a:spcPts val="900"/>
+              </a:spcAft>
+              <a:defRPr sz="1600" b="0">
+                <a:solidFill>
+                  <a:srgbClr val="132C38"/>
+                </a:solidFill>
+                <a:latin typeface="DejaVu Sans"/>
+              </a:defRPr>
+            </a:pPr>
+            <a:r>
+              <a:t>Briefing PDF + PowerPoint + slide PDF</a:t>
+            </a:r>
+          </a:p>
+          <a:p>
+            <a:pPr>
+              <a:spcAft>
+                <a:spcPts val="900"/>
+              </a:spcAft>
+              <a:defRPr sz="1600" b="0">
+                <a:solidFill>
+                  <a:srgbClr val="132C38"/>
+                </a:solidFill>
+                <a:latin typeface="DejaVu Sans"/>
+              </a:defRPr>
+            </a:pPr>
+            <a:r>
+              <a:t>Runbook + talk track + recorded demo</a:t>
+            </a:r>
+          </a:p>
+        </p:txBody>
+      </p:sp>
+      <p:sp>
+        <p:nvSpPr>
+          <p:cNvPr id="10" name="Rectangle 9"/>
+          <p:cNvSpPr/>
+          <p:nvPr/>
+        </p:nvSpPr>
+        <p:spPr>
+          <a:xfrm>
+            <a:off x="4328160" y="2423160"/>
+            <a:ext cx="3532632" cy="2880360"/>
+          </a:xfrm>
+          <a:prstGeom prst="rect">
+            <a:avLst/>
+          </a:prstGeom>
+          <a:solidFill>
+            <a:srgbClr val="FFFFFF"/>
+          </a:solidFill>
+          <a:ln>
+            <a:noFill/>
+          </a:ln>
+        </p:spPr>
+        <p:style>
+          <a:lnRef idx="1">
+            <a:schemeClr val="accent1"/>
+          </a:lnRef>
+          <a:fillRef idx="3">
+            <a:schemeClr val="accent1"/>
+          </a:fillRef>
+          <a:effectRef idx="2">
+            <a:schemeClr val="accent1"/>
+          </a:effectRef>
+          <a:fontRef idx="minor">
+            <a:schemeClr val="lt1"/>
+          </a:fontRef>
+        </p:style>
+        <p:txBody>
+          <a:bodyPr rtlCol="0" anchor="ctr"/>
+          <a:lstStyle/>
+          <a:p>
+            <a:pPr algn="ctr"/>
+          </a:p>
+        </p:txBody>
+      </p:sp>
+      <p:sp>
+        <p:nvSpPr>
+          <p:cNvPr id="11" name="Rectangle 10"/>
+          <p:cNvSpPr/>
+          <p:nvPr/>
+        </p:nvSpPr>
+        <p:spPr>
+          <a:xfrm>
+            <a:off x="4328160" y="2423160"/>
+            <a:ext cx="3532632" cy="50292"/>
+          </a:xfrm>
+          <a:prstGeom prst="rect">
+            <a:avLst/>
+          </a:prstGeom>
+          <a:solidFill>
+            <a:srgbClr val="007C78"/>
+          </a:solidFill>
+          <a:ln>
+            <a:noFill/>
+          </a:ln>
+        </p:spPr>
+        <p:style>
+          <a:lnRef idx="1">
+            <a:schemeClr val="accent1"/>
+          </a:lnRef>
+          <a:fillRef idx="3">
+            <a:schemeClr val="accent1"/>
+          </a:fillRef>
+          <a:effectRef idx="2">
+            <a:schemeClr val="accent1"/>
+          </a:effectRef>
+          <a:fontRef idx="minor">
+            <a:schemeClr val="lt1"/>
+          </a:fontRef>
+        </p:style>
+        <p:txBody>
+          <a:bodyPr rtlCol="0" anchor="ctr"/>
+          <a:lstStyle/>
+          <a:p>
+            <a:pPr algn="ctr"/>
+          </a:p>
+        </p:txBody>
+      </p:sp>
+      <p:sp>
+        <p:nvSpPr>
+          <p:cNvPr id="12" name="TextBox 11"/>
+          <p:cNvSpPr txBox="1"/>
+          <p:nvPr/>
+        </p:nvSpPr>
+        <p:spPr>
+          <a:xfrm>
+            <a:off x="4529328" y="2606040"/>
+            <a:ext cx="3130296" cy="457200"/>
+          </a:xfrm>
+          <a:prstGeom prst="rect">
+            <a:avLst/>
+          </a:prstGeom>
+          <a:noFill/>
+        </p:spPr>
+        <p:txBody>
+          <a:bodyPr wrap="square" lIns="18288" rIns="18288" tIns="0" bIns="0">
+            <a:spAutoFit/>
+          </a:bodyPr>
+          <a:lstStyle/>
+          <a:p>
+            <a:pPr>
+              <a:spcAft>
+                <a:spcPts val="900"/>
+              </a:spcAft>
+              <a:defRPr sz="2100" b="1">
+                <a:solidFill>
+                  <a:srgbClr val="007C78"/>
+                </a:solidFill>
+                <a:latin typeface="DejaVu Sans"/>
+              </a:defRPr>
+            </a:pPr>
+            <a:r>
+              <a:t>Verify results</a:t>
+            </a:r>
+          </a:p>
+        </p:txBody>
+      </p:sp>
+      <p:sp>
+        <p:nvSpPr>
+          <p:cNvPr id="13" name="TextBox 12"/>
+          <p:cNvSpPr txBox="1"/>
+          <p:nvPr/>
+        </p:nvSpPr>
+        <p:spPr>
+          <a:xfrm>
+            <a:off x="4529328" y="3264408"/>
+            <a:ext cx="3130296" cy="1920239"/>
+          </a:xfrm>
+          <a:prstGeom prst="rect">
+            <a:avLst/>
+          </a:prstGeom>
+          <a:noFill/>
+        </p:spPr>
+        <p:txBody>
+          <a:bodyPr wrap="square" lIns="18288" rIns="18288" tIns="0" bIns="0">
+            <a:spAutoFit/>
+          </a:bodyPr>
+          <a:lstStyle/>
+          <a:p>
+            <a:pPr>
+              <a:spcAft>
+                <a:spcPts val="900"/>
+              </a:spcAft>
+              <a:defRPr sz="1600" b="0">
+                <a:solidFill>
+                  <a:srgbClr val="132C38"/>
+                </a:solidFill>
+                <a:latin typeface="DejaVu Sans"/>
+              </a:defRPr>
+            </a:pPr>
+            <a:r>
+              <a:t>evidence/results.json</a:t>
+            </a:r>
+          </a:p>
+          <a:p>
+            <a:pPr>
+              <a:spcAft>
+                <a:spcPts val="900"/>
+              </a:spcAft>
+              <a:defRPr sz="1600" b="0">
+                <a:solidFill>
+                  <a:srgbClr val="132C38"/>
+                </a:solidFill>
+                <a:latin typeface="DejaVu Sans"/>
+              </a:defRPr>
+            </a:pPr>
+            <a:r>
+              <a:t>Per-seed manifests, epoch logs and predictions</a:t>
+            </a:r>
+          </a:p>
+          <a:p>
+            <a:pPr>
+              <a:spcAft>
+                <a:spcPts val="900"/>
+              </a:spcAft>
+              <a:defRPr sz="1600" b="0">
+                <a:solidFill>
+                  <a:srgbClr val="132C38"/>
+                </a:solidFill>
+                <a:latin typeface="DejaVu Sans"/>
+              </a:defRPr>
+            </a:pPr>
+            <a:r>
+              <a:t>Runtime parity + build records + benchmark</a:t>
+            </a:r>
+          </a:p>
+        </p:txBody>
+      </p:sp>
+      <p:sp>
+        <p:nvSpPr>
+          <p:cNvPr id="14" name="Rectangle 13"/>
+          <p:cNvSpPr/>
+          <p:nvPr/>
+        </p:nvSpPr>
+        <p:spPr>
+          <a:xfrm>
+            <a:off x="8061960" y="2423160"/>
+            <a:ext cx="3532632" cy="2880360"/>
+          </a:xfrm>
+          <a:prstGeom prst="rect">
+            <a:avLst/>
+          </a:prstGeom>
+          <a:solidFill>
+            <a:srgbClr val="FFFFFF"/>
+          </a:solidFill>
+          <a:ln>
+            <a:noFill/>
+          </a:ln>
+        </p:spPr>
+        <p:style>
+          <a:lnRef idx="1">
+            <a:schemeClr val="accent1"/>
+          </a:lnRef>
+          <a:fillRef idx="3">
+            <a:schemeClr val="accent1"/>
+          </a:fillRef>
+          <a:effectRef idx="2">
+            <a:schemeClr val="accent1"/>
+          </a:effectRef>
+          <a:fontRef idx="minor">
+            <a:schemeClr val="lt1"/>
+          </a:fontRef>
+        </p:style>
+        <p:txBody>
+          <a:bodyPr rtlCol="0" anchor="ctr"/>
+          <a:lstStyle/>
+          <a:p>
+            <a:pPr algn="ctr"/>
+          </a:p>
+        </p:txBody>
+      </p:sp>
+      <p:sp>
+        <p:nvSpPr>
+          <p:cNvPr id="15" name="Rectangle 14"/>
+          <p:cNvSpPr/>
+          <p:nvPr/>
+        </p:nvSpPr>
+        <p:spPr>
+          <a:xfrm>
+            <a:off x="8061960" y="2423160"/>
+            <a:ext cx="3532632" cy="50292"/>
+          </a:xfrm>
+          <a:prstGeom prst="rect">
+            <a:avLst/>
+          </a:prstGeom>
+          <a:solidFill>
+            <a:srgbClr val="007C78"/>
+          </a:solidFill>
+          <a:ln>
+            <a:noFill/>
+          </a:ln>
+        </p:spPr>
+        <p:style>
+          <a:lnRef idx="1">
+            <a:schemeClr val="accent1"/>
+          </a:lnRef>
+          <a:fillRef idx="3">
+            <a:schemeClr val="accent1"/>
+          </a:fillRef>
+          <a:effectRef idx="2">
+            <a:schemeClr val="accent1"/>
+          </a:effectRef>
+          <a:fontRef idx="minor">
+            <a:schemeClr val="lt1"/>
+          </a:fontRef>
+        </p:style>
+        <p:txBody>
+          <a:bodyPr rtlCol="0" anchor="ctr"/>
+          <a:lstStyle/>
+          <a:p>
+            <a:pPr algn="ctr"/>
+          </a:p>
+        </p:txBody>
+      </p:sp>
+      <p:sp>
+        <p:nvSpPr>
+          <p:cNvPr id="16" name="TextBox 15"/>
+          <p:cNvSpPr txBox="1"/>
+          <p:nvPr/>
+        </p:nvSpPr>
+        <p:spPr>
+          <a:xfrm>
+            <a:off x="8263128" y="2606040"/>
+            <a:ext cx="3130296" cy="457200"/>
+          </a:xfrm>
+          <a:prstGeom prst="rect">
+            <a:avLst/>
+          </a:prstGeom>
+          <a:noFill/>
+        </p:spPr>
+        <p:txBody>
+          <a:bodyPr wrap="square" lIns="18288" rIns="18288" tIns="0" bIns="0">
+            <a:spAutoFit/>
+          </a:bodyPr>
+          <a:lstStyle/>
+          <a:p>
+            <a:pPr>
+              <a:spcAft>
+                <a:spcPts val="900"/>
+              </a:spcAft>
+              <a:defRPr sz="2100" b="1">
+                <a:solidFill>
+                  <a:srgbClr val="007C78"/>
+                </a:solidFill>
+                <a:latin typeface="DejaVu Sans"/>
+              </a:defRPr>
+            </a:pPr>
+            <a:r>
+              <a:t>Read the research</a:t>
+            </a:r>
+          </a:p>
+        </p:txBody>
+      </p:sp>
+      <p:sp>
+        <p:nvSpPr>
+          <p:cNvPr id="17" name="TextBox 16"/>
+          <p:cNvSpPr txBox="1"/>
+          <p:nvPr/>
+        </p:nvSpPr>
+        <p:spPr>
+          <a:xfrm>
+            <a:off x="8263128" y="3264408"/>
+            <a:ext cx="3130296" cy="1920239"/>
+          </a:xfrm>
+          <a:prstGeom prst="rect">
+            <a:avLst/>
+          </a:prstGeom>
+          <a:noFill/>
+        </p:spPr>
+        <p:txBody>
+          <a:bodyPr wrap="square" lIns="18288" rIns="18288" tIns="0" bIns="0">
+            <a:spAutoFit/>
+          </a:bodyPr>
+          <a:lstStyle/>
+          <a:p>
+            <a:pPr>
+              <a:spcAft>
+                <a:spcPts val="900"/>
+              </a:spcAft>
+              <a:defRPr sz="1600" b="0">
+                <a:solidFill>
+                  <a:srgbClr val="132C38"/>
+                </a:solidFill>
+                <a:latin typeface="DejaVu Sans"/>
+              </a:defRPr>
+            </a:pPr>
+            <a:r>
+              <a:t>docs/research/research-record.md</a:t>
+            </a:r>
+          </a:p>
+          <a:p>
+            <a:pPr>
+              <a:spcAft>
+                <a:spcPts val="900"/>
+              </a:spcAft>
+              <a:defRPr sz="1600" b="0">
+                <a:solidFill>
+                  <a:srgbClr val="132C38"/>
+                </a:solidFill>
+                <a:latin typeface="DejaVu Sans"/>
+              </a:defRPr>
+            </a:pPr>
+            <a:r>
+              <a:t>Pinned paper/source links</a:t>
+            </a:r>
+          </a:p>
+          <a:p>
+            <a:pPr>
+              <a:spcAft>
+                <a:spcPts val="900"/>
+              </a:spcAft>
+              <a:defRPr sz="1600" b="0">
+                <a:solidFill>
+                  <a:srgbClr val="132C38"/>
+                </a:solidFill>
+                <a:latin typeface="DejaVu Sans"/>
+              </a:defRPr>
+            </a:pPr>
+            <a:r>
+              <a:t>Exact council decision and its evidence limits</a:t>
+            </a:r>
+          </a:p>
+        </p:txBody>
+      </p:sp>
+      <p:sp>
+        <p:nvSpPr>
+          <p:cNvPr id="18" name="Rectangle 17"/>
+          <p:cNvSpPr/>
+          <p:nvPr/>
+        </p:nvSpPr>
+        <p:spPr>
+          <a:xfrm>
+            <a:off x="594360" y="5806440"/>
+            <a:ext cx="11000232" cy="512064"/>
+          </a:xfrm>
+          <a:prstGeom prst="rect">
+            <a:avLst/>
+          </a:prstGeom>
+          <a:solidFill>
+            <a:srgbClr val="E0EAE3"/>
+          </a:solidFill>
+          <a:ln>
+            <a:noFill/>
+          </a:ln>
+        </p:spPr>
+        <p:style>
+          <a:lnRef idx="1">
+            <a:schemeClr val="accent1"/>
+          </a:lnRef>
+          <a:fillRef idx="3">
+            <a:schemeClr val="accent1"/>
+          </a:fillRef>
+          <a:effectRef idx="2">
+            <a:schemeClr val="accent1"/>
+          </a:effectRef>
+          <a:fontRef idx="minor">
+            <a:schemeClr val="lt1"/>
+          </a:fontRef>
+        </p:style>
+        <p:txBody>
+          <a:bodyPr rtlCol="0" anchor="ctr"/>
+          <a:lstStyle/>
+          <a:p>
+            <a:pPr algn="ctr"/>
+          </a:p>
+        </p:txBody>
+      </p:sp>
+      <p:sp>
+        <p:nvSpPr>
+          <p:cNvPr id="19" name="TextBox 18"/>
+          <p:cNvSpPr txBox="1"/>
+          <p:nvPr/>
+        </p:nvSpPr>
+        <p:spPr>
+          <a:xfrm>
+            <a:off x="731520" y="5897880"/>
+            <a:ext cx="10735056" cy="365760"/>
+          </a:xfrm>
+          <a:prstGeom prst="rect">
+            <a:avLst/>
+          </a:prstGeom>
+          <a:noFill/>
+        </p:spPr>
+        <p:txBody>
+          <a:bodyPr wrap="square" lIns="18288" rIns="18288" tIns="0" bIns="0">
+            <a:spAutoFit/>
+          </a:bodyPr>
+          <a:lstStyle/>
+          <a:p>
+            <a:pPr>
+              <a:spcAft>
+                <a:spcPts val="900"/>
+              </a:spcAft>
+              <a:defRPr sz="1250" b="0">
+                <a:solidFill>
+                  <a:srgbClr val="132C38"/>
+                </a:solidFill>
+                <a:latin typeface="DejaVu Sans"/>
+              </a:defRPr>
+            </a:pPr>
+            <a:r>
+              <a:t>github.com/buffbeefalo/netmambaplus-reproduction</a:t>
+            </a:r>
+          </a:p>
+        </p:txBody>
+      </p:sp>
+      <p:sp>
+        <p:nvSpPr>
+          <p:cNvPr id="20" name="TextBox 19"/>
+          <p:cNvSpPr txBox="1"/>
+          <p:nvPr/>
+        </p:nvSpPr>
+        <p:spPr>
+          <a:xfrm>
+            <a:off x="594360" y="6519672"/>
+            <a:ext cx="10424160" cy="182880"/>
+          </a:xfrm>
+          <a:prstGeom prst="rect">
+            <a:avLst/>
+          </a:prstGeom>
+          <a:noFill/>
+        </p:spPr>
+        <p:txBody>
+          <a:bodyPr wrap="square" lIns="18288" rIns="18288" tIns="0" bIns="0">
+            <a:spAutoFit/>
+          </a:bodyPr>
+          <a:lstStyle/>
+          <a:p>
+            <a:pPr>
+              <a:spcAft>
+                <a:spcPts val="900"/>
+              </a:spcAft>
+              <a:defRPr sz="900" b="0">
+                <a:solidFill>
+                  <a:srgbClr val="516774"/>
+                </a:solidFill>
+                <a:latin typeface="DejaVu Sans"/>
+              </a:defRPr>
+            </a:pPr>
+            <a:r>
+              <a:rPr>
+                <a:hlinkClick r:id="rId3"/>
+              </a:rPr>
+              <a:t>NETMAMBA+  /  MEASURED RESEARCH  /  15 September 2026</a:t>
+            </a:r>
+          </a:p>
+        </p:txBody>
+      </p:sp>
+      <p:sp>
+        <p:nvSpPr>
+          <p:cNvPr id="21" name="TextBox 20"/>
+          <p:cNvSpPr txBox="1"/>
+          <p:nvPr/>
+        </p:nvSpPr>
+        <p:spPr>
+          <a:xfrm>
+            <a:off x="11155680" y="6473952"/>
+            <a:ext cx="457200" cy="228600"/>
+          </a:xfrm>
+          <a:prstGeom prst="rect">
+            <a:avLst/>
+          </a:prstGeom>
+          <a:noFill/>
+        </p:spPr>
+        <p:txBody>
+          <a:bodyPr wrap="square" lIns="18288" rIns="18288" tIns="0" bIns="0">
+            <a:spAutoFit/>
+          </a:bodyPr>
+          <a:lstStyle/>
+          <a:p>
+            <a:pPr>
+              <a:spcAft>
+                <a:spcPts val="900"/>
+              </a:spcAft>
+              <a:defRPr sz="1100" b="0">
+                <a:solidFill>
+                  <a:srgbClr val="516774"/>
+                </a:solidFill>
+                <a:latin typeface="DejaVu Sans"/>
+              </a:defRPr>
+            </a:pPr>
+            <a:r>
+              <a:t>16</a:t>
             </a:r>
           </a:p>
         </p:txBody>

</xml_diff>